<commit_message>
Make solution, technology and market slides easier to read
Slide 6 shows the priority report as numbered risk markers on a
platform photo; slide 7 replaces the scatter plot with surface photo,
rust color and corrosion-rate bars per risk level; slide 9 swaps the
TAM/SAM/SOM placeholders for the Gulf of Mexico platform count (BSEE),
buying motives and entry order. Slide 3 notes that AMPP still cites
the IMPACT figure in 2025. Notes and the Word script follow.

Co-Authored-By: Claude Opus 5.5 <noreply@anthropic.com>
Claude-Session: https://claude.ai/code/session_01WJhUeJknrpz3z9hRfyX3tP
</commit_message>
<xml_diff>
--- a/MLC_IR_A-STREAM2026.pptx
+++ b/MLC_IR_A-STREAM2026.pptx
@@ -120,544 +120,6 @@
     </p:ext>
   </p:extLst>
 </p:presentation>
-</file>
-
-<file path=ppt/charts/chart1.xml><?xml version="1.0" encoding="utf-8"?>
-<c:chartSpace xmlns:c="http://schemas.openxmlformats.org/drawingml/2006/chart" xmlns:a="http://schemas.openxmlformats.org/drawingml/2006/main" xmlns:r="http://schemas.openxmlformats.org/officeDocument/2006/relationships" xmlns:c16r2="http://schemas.microsoft.com/office/drawing/2015/06/chart">
-  <c:date1904 val="0"/>
-  <c:lang val="ko-KR"/>
-  <c:roundedCorners val="1"/>
-  <c:style val="2"/>
-  <c:chart>
-    <c:autoTitleDeleted val="1"/>
-    <c:plotArea>
-      <c:layout>
-        <c:manualLayout>
-          <c:layoutTarget val="inner"/>
-          <c:xMode val="edge"/>
-          <c:yMode val="edge"/>
-          <c:x val="0.11"/>
-          <c:y val="0.04"/>
-          <c:w val="0.85"/>
-          <c:h val="0.82"/>
-        </c:manualLayout>
-      </c:layout>
-      <c:scatterChart>
-        <c:scatterStyle val="lineMarker"/>
-        <c:varyColors val="0"/>
-        <c:ser>
-          <c:idx val="0"/>
-          <c:order val="0"/>
-          <c:tx>
-            <c:strRef>
-              <c:f>Sheet1!$B$1</c:f>
-              <c:strCache>
-                <c:ptCount val="1"/>
-                <c:pt idx="0">
-                  <c:v>Incubation</c:v>
-                </c:pt>
-              </c:strCache>
-            </c:strRef>
-          </c:tx>
-          <c:spPr>
-            <a:ln>
-              <a:noFill/>
-            </a:ln>
-            <a:effectLst/>
-          </c:spPr>
-          <c:marker>
-            <c:symbol val="circle"/>
-            <c:size val="13"/>
-            <c:spPr>
-              <a:solidFill>
-                <a:srgbClr val="3A6EA5"/>
-              </a:solidFill>
-              <a:ln w="19050" cap="flat">
-                <a:solidFill>
-                  <a:srgbClr val="FFFFFF"/>
-                </a:solidFill>
-                <a:prstDash val="solid"/>
-                <a:round/>
-              </a:ln>
-              <a:effectLst/>
-            </c:spPr>
-          </c:marker>
-          <c:xVal>
-            <c:numRef>
-              <c:f>Sheet1!$A$2:$A$10</c:f>
-              <c:numCache>
-                <c:formatCode>General</c:formatCode>
-                <c:ptCount val="9"/>
-                <c:pt idx="0">
-                  <c:v>-0.2</c:v>
-                </c:pt>
-                <c:pt idx="1">
-                  <c:v>2.1</c:v>
-                </c:pt>
-                <c:pt idx="2">
-                  <c:v>2.7</c:v>
-                </c:pt>
-                <c:pt idx="3">
-                  <c:v>2.2999999999999998</c:v>
-                </c:pt>
-                <c:pt idx="4">
-                  <c:v>6.6</c:v>
-                </c:pt>
-                <c:pt idx="5">
-                  <c:v>12.2</c:v>
-                </c:pt>
-                <c:pt idx="6">
-                  <c:v>13.2</c:v>
-                </c:pt>
-                <c:pt idx="7">
-                  <c:v>13.9</c:v>
-                </c:pt>
-                <c:pt idx="8">
-                  <c:v>12.1</c:v>
-                </c:pt>
-              </c:numCache>
-            </c:numRef>
-          </c:xVal>
-          <c:yVal>
-            <c:numRef>
-              <c:f>Sheet1!$B$2:$B$10</c:f>
-              <c:numCache>
-                <c:formatCode>General</c:formatCode>
-                <c:ptCount val="9"/>
-                <c:pt idx="0">
-                  <c:v>0.32400000000000001</c:v>
-                </c:pt>
-                <c:pt idx="1">
-                  <c:v>0.193</c:v>
-                </c:pt>
-                <c:pt idx="2">
-                  <c:v>0.44700000000000001</c:v>
-                </c:pt>
-                <c:pt idx="3">
-                  <c:v>0.40600000000000003</c:v>
-                </c:pt>
-              </c:numCache>
-            </c:numRef>
-          </c:yVal>
-          <c:smooth val="0"/>
-          <c:extLst>
-            <c:ext xmlns:c16="http://schemas.microsoft.com/office/drawing/2014/chart" uri="{C3380CC4-5D6E-409C-BE32-E72D297353CC}">
-              <c16:uniqueId val="{00000000-B1E0-49F6-9E21-CECE0282E43A}"/>
-            </c:ext>
-          </c:extLst>
-        </c:ser>
-        <c:ser>
-          <c:idx val="1"/>
-          <c:order val="1"/>
-          <c:tx>
-            <c:strRef>
-              <c:f>Sheet1!$C$1</c:f>
-              <c:strCache>
-                <c:ptCount val="1"/>
-                <c:pt idx="0">
-                  <c:v>Propagation</c:v>
-                </c:pt>
-              </c:strCache>
-            </c:strRef>
-          </c:tx>
-          <c:spPr>
-            <a:ln>
-              <a:noFill/>
-            </a:ln>
-            <a:effectLst/>
-          </c:spPr>
-          <c:marker>
-            <c:symbol val="circle"/>
-            <c:size val="13"/>
-            <c:spPr>
-              <a:solidFill>
-                <a:srgbClr val="3C8D5A"/>
-              </a:solidFill>
-              <a:ln w="19050" cap="flat">
-                <a:solidFill>
-                  <a:srgbClr val="FFFFFF"/>
-                </a:solidFill>
-                <a:prstDash val="solid"/>
-                <a:round/>
-              </a:ln>
-              <a:effectLst/>
-            </c:spPr>
-          </c:marker>
-          <c:xVal>
-            <c:numRef>
-              <c:f>Sheet1!$A$2:$A$10</c:f>
-              <c:numCache>
-                <c:formatCode>General</c:formatCode>
-                <c:ptCount val="9"/>
-                <c:pt idx="0">
-                  <c:v>-0.2</c:v>
-                </c:pt>
-                <c:pt idx="1">
-                  <c:v>2.1</c:v>
-                </c:pt>
-                <c:pt idx="2">
-                  <c:v>2.7</c:v>
-                </c:pt>
-                <c:pt idx="3">
-                  <c:v>2.2999999999999998</c:v>
-                </c:pt>
-                <c:pt idx="4">
-                  <c:v>6.6</c:v>
-                </c:pt>
-                <c:pt idx="5">
-                  <c:v>12.2</c:v>
-                </c:pt>
-                <c:pt idx="6">
-                  <c:v>13.2</c:v>
-                </c:pt>
-                <c:pt idx="7">
-                  <c:v>13.9</c:v>
-                </c:pt>
-                <c:pt idx="8">
-                  <c:v>12.1</c:v>
-                </c:pt>
-              </c:numCache>
-            </c:numRef>
-          </c:xVal>
-          <c:yVal>
-            <c:numRef>
-              <c:f>Sheet1!$C$2:$C$10</c:f>
-              <c:numCache>
-                <c:formatCode>General</c:formatCode>
-                <c:ptCount val="9"/>
-                <c:pt idx="4">
-                  <c:v>0.52400000000000002</c:v>
-                </c:pt>
-                <c:pt idx="5">
-                  <c:v>0.83799999999999997</c:v>
-                </c:pt>
-              </c:numCache>
-            </c:numRef>
-          </c:yVal>
-          <c:smooth val="0"/>
-          <c:extLst>
-            <c:ext xmlns:c16="http://schemas.microsoft.com/office/drawing/2014/chart" uri="{C3380CC4-5D6E-409C-BE32-E72D297353CC}">
-              <c16:uniqueId val="{00000001-B1E0-49F6-9E21-CECE0282E43A}"/>
-            </c:ext>
-          </c:extLst>
-        </c:ser>
-        <c:ser>
-          <c:idx val="2"/>
-          <c:order val="2"/>
-          <c:tx>
-            <c:strRef>
-              <c:f>Sheet1!$D$1</c:f>
-              <c:strCache>
-                <c:ptCount val="1"/>
-                <c:pt idx="0">
-                  <c:v>Maturation</c:v>
-                </c:pt>
-              </c:strCache>
-            </c:strRef>
-          </c:tx>
-          <c:spPr>
-            <a:ln>
-              <a:noFill/>
-            </a:ln>
-            <a:effectLst/>
-          </c:spPr>
-          <c:marker>
-            <c:symbol val="circle"/>
-            <c:size val="13"/>
-            <c:spPr>
-              <a:solidFill>
-                <a:srgbClr val="B23A2E"/>
-              </a:solidFill>
-              <a:ln w="19050" cap="flat">
-                <a:solidFill>
-                  <a:srgbClr val="FFFFFF"/>
-                </a:solidFill>
-                <a:prstDash val="solid"/>
-                <a:round/>
-              </a:ln>
-              <a:effectLst/>
-            </c:spPr>
-          </c:marker>
-          <c:xVal>
-            <c:numRef>
-              <c:f>Sheet1!$A$2:$A$10</c:f>
-              <c:numCache>
-                <c:formatCode>General</c:formatCode>
-                <c:ptCount val="9"/>
-                <c:pt idx="0">
-                  <c:v>-0.2</c:v>
-                </c:pt>
-                <c:pt idx="1">
-                  <c:v>2.1</c:v>
-                </c:pt>
-                <c:pt idx="2">
-                  <c:v>2.7</c:v>
-                </c:pt>
-                <c:pt idx="3">
-                  <c:v>2.2999999999999998</c:v>
-                </c:pt>
-                <c:pt idx="4">
-                  <c:v>6.6</c:v>
-                </c:pt>
-                <c:pt idx="5">
-                  <c:v>12.2</c:v>
-                </c:pt>
-                <c:pt idx="6">
-                  <c:v>13.2</c:v>
-                </c:pt>
-                <c:pt idx="7">
-                  <c:v>13.9</c:v>
-                </c:pt>
-                <c:pt idx="8">
-                  <c:v>12.1</c:v>
-                </c:pt>
-              </c:numCache>
-            </c:numRef>
-          </c:xVal>
-          <c:yVal>
-            <c:numRef>
-              <c:f>Sheet1!$D$2:$D$10</c:f>
-              <c:numCache>
-                <c:formatCode>General</c:formatCode>
-                <c:ptCount val="9"/>
-                <c:pt idx="6">
-                  <c:v>1.1759999999999999</c:v>
-                </c:pt>
-                <c:pt idx="7">
-                  <c:v>1.4139999999999999</c:v>
-                </c:pt>
-                <c:pt idx="8">
-                  <c:v>1.7450000000000001</c:v>
-                </c:pt>
-              </c:numCache>
-            </c:numRef>
-          </c:yVal>
-          <c:smooth val="0"/>
-          <c:extLst>
-            <c:ext xmlns:c16="http://schemas.microsoft.com/office/drawing/2014/chart" uri="{C3380CC4-5D6E-409C-BE32-E72D297353CC}">
-              <c16:uniqueId val="{00000002-B1E0-49F6-9E21-CECE0282E43A}"/>
-            </c:ext>
-          </c:extLst>
-        </c:ser>
-        <c:dLbls>
-          <c:showLegendKey val="0"/>
-          <c:showVal val="0"/>
-          <c:showCatName val="0"/>
-          <c:showSerName val="0"/>
-          <c:showPercent val="0"/>
-          <c:showBubbleSize val="0"/>
-        </c:dLbls>
-        <c:axId val="2094734554"/>
-        <c:axId val="2094734552"/>
-      </c:scatterChart>
-      <c:valAx>
-        <c:axId val="2094734554"/>
-        <c:scaling>
-          <c:orientation val="minMax"/>
-          <c:max val="16"/>
-          <c:min val="-2"/>
-        </c:scaling>
-        <c:delete val="0"/>
-        <c:axPos val="b"/>
-        <c:title>
-          <c:tx>
-            <c:rich>
-              <a:bodyPr/>
-              <a:lstStyle/>
-              <a:p>
-                <a:pPr>
-                  <a:defRPr sz="1200" b="0" i="0" u="none" strike="noStrike">
-                    <a:solidFill>
-                      <a:srgbClr val="6B6F76"/>
-                    </a:solidFill>
-                    <a:latin typeface="맑은 고딕"/>
-                  </a:defRPr>
-                </a:pPr>
-                <a:r>
-                  <a:rPr lang="en-US" sz="1200" b="0" i="0" u="none" strike="noStrike">
-                    <a:solidFill>
-                      <a:srgbClr val="6B6F76"/>
-                    </a:solidFill>
-                    <a:latin typeface="맑은 고딕"/>
-                  </a:rPr>
-                  <a:t>b*</a:t>
-                </a:r>
-              </a:p>
-            </c:rich>
-          </c:tx>
-          <c:overlay val="0"/>
-        </c:title>
-        <c:numFmt formatCode="General" sourceLinked="1"/>
-        <c:majorTickMark val="none"/>
-        <c:minorTickMark val="none"/>
-        <c:tickLblPos val="nextTo"/>
-        <c:spPr>
-          <a:ln w="12700" cap="flat">
-            <a:solidFill>
-              <a:srgbClr val="A3A7AD"/>
-            </a:solidFill>
-            <a:prstDash val="solid"/>
-            <a:round/>
-          </a:ln>
-        </c:spPr>
-        <c:txPr>
-          <a:bodyPr/>
-          <a:lstStyle/>
-          <a:p>
-            <a:pPr>
-              <a:defRPr sz="1100" b="0" i="0" u="none" strike="noStrike">
-                <a:solidFill>
-                  <a:srgbClr val="6B6F76"/>
-                </a:solidFill>
-                <a:latin typeface="맑은 고딕"/>
-              </a:defRPr>
-            </a:pPr>
-            <a:endParaRPr lang="ko-KR"/>
-          </a:p>
-        </c:txPr>
-        <c:crossAx val="2094734552"/>
-        <c:crosses val="autoZero"/>
-        <c:crossBetween val="midCat"/>
-        <c:majorUnit val="2"/>
-      </c:valAx>
-      <c:valAx>
-        <c:axId val="2094734552"/>
-        <c:scaling>
-          <c:orientation val="minMax"/>
-          <c:max val="2"/>
-          <c:min val="0"/>
-        </c:scaling>
-        <c:delete val="0"/>
-        <c:axPos val="l"/>
-        <c:majorGridlines>
-          <c:spPr>
-            <a:ln w="9525" cap="flat">
-              <a:solidFill>
-                <a:srgbClr val="E6E8EB"/>
-              </a:solidFill>
-              <a:prstDash val="solid"/>
-              <a:round/>
-            </a:ln>
-          </c:spPr>
-        </c:majorGridlines>
-        <c:title>
-          <c:tx>
-            <c:rich>
-              <a:bodyPr/>
-              <a:lstStyle/>
-              <a:p>
-                <a:pPr>
-                  <a:defRPr sz="1200" b="0" i="0" u="none" strike="noStrike">
-                    <a:solidFill>
-                      <a:srgbClr val="6B6F76"/>
-                    </a:solidFill>
-                    <a:latin typeface="맑은 고딕"/>
-                  </a:defRPr>
-                </a:pPr>
-                <a:r>
-                  <a:rPr lang="ko-KR" altLang="en-US" sz="1200" b="0" i="0" u="none" strike="noStrike">
-                    <a:solidFill>
-                      <a:srgbClr val="6B6F76"/>
-                    </a:solidFill>
-                    <a:latin typeface="맑은 고딕"/>
-                  </a:rPr>
-                  <a:t>부식 속도 </a:t>
-                </a:r>
-                <a:r>
-                  <a:rPr lang="en-US" altLang="ko-KR" sz="1200" b="0" i="0" u="none" strike="noStrike">
-                    <a:solidFill>
-                      <a:srgbClr val="6B6F76"/>
-                    </a:solidFill>
-                    <a:latin typeface="맑은 고딕"/>
-                  </a:rPr>
-                  <a:t>(</a:t>
-                </a:r>
-                <a:r>
-                  <a:rPr lang="en-US" sz="1200" b="0" i="0" u="none" strike="noStrike">
-                    <a:solidFill>
-                      <a:srgbClr val="6B6F76"/>
-                    </a:solidFill>
-                    <a:latin typeface="맑은 고딕"/>
-                  </a:rPr>
-                  <a:t>mm/</a:t>
-                </a:r>
-                <a:r>
-                  <a:rPr lang="ko-KR" altLang="en-US" sz="1200" b="0" i="0" u="none" strike="noStrike">
-                    <a:solidFill>
-                      <a:srgbClr val="6B6F76"/>
-                    </a:solidFill>
-                    <a:latin typeface="맑은 고딕"/>
-                  </a:rPr>
-                  <a:t>년</a:t>
-                </a:r>
-                <a:r>
-                  <a:rPr lang="en-US" altLang="ko-KR" sz="1200" b="0" i="0" u="none" strike="noStrike">
-                    <a:solidFill>
-                      <a:srgbClr val="6B6F76"/>
-                    </a:solidFill>
-                    <a:latin typeface="맑은 고딕"/>
-                  </a:rPr>
-                  <a:t>)</a:t>
-                </a:r>
-              </a:p>
-            </c:rich>
-          </c:tx>
-          <c:overlay val="0"/>
-        </c:title>
-        <c:numFmt formatCode="General" sourceLinked="0"/>
-        <c:majorTickMark val="none"/>
-        <c:minorTickMark val="none"/>
-        <c:tickLblPos val="nextTo"/>
-        <c:spPr>
-          <a:ln w="12700" cap="flat">
-            <a:noFill/>
-            <a:prstDash val="solid"/>
-            <a:round/>
-          </a:ln>
-        </c:spPr>
-        <c:txPr>
-          <a:bodyPr/>
-          <a:lstStyle/>
-          <a:p>
-            <a:pPr>
-              <a:defRPr sz="1100" b="0" i="0" u="none" strike="noStrike">
-                <a:solidFill>
-                  <a:srgbClr val="6B6F76"/>
-                </a:solidFill>
-                <a:latin typeface="맑은 고딕"/>
-              </a:defRPr>
-            </a:pPr>
-            <a:endParaRPr lang="ko-KR"/>
-          </a:p>
-        </c:txPr>
-        <c:crossAx val="2094734554"/>
-        <c:crossesAt val="-2"/>
-        <c:crossBetween val="midCat"/>
-        <c:majorUnit val="0.5"/>
-      </c:valAx>
-      <c:spPr>
-        <a:noFill/>
-        <a:ln>
-          <a:noFill/>
-        </a:ln>
-        <a:effectLst/>
-      </c:spPr>
-    </c:plotArea>
-    <c:plotVisOnly val="1"/>
-    <c:dispBlanksAs val="span"/>
-    <c:showDLblsOverMax val="1"/>
-  </c:chart>
-  <c:spPr>
-    <a:noFill/>
-    <a:ln>
-      <a:noFill/>
-    </a:ln>
-    <a:effectLst/>
-  </c:spPr>
-  <c:externalData r:id="rId1">
-    <c:autoUpdate val="0"/>
-  </c:externalData>
-</c:chartSpace>
 </file>
 
 <file path=ppt/notesMasters/notesMaster1.xml><?xml version="1.0" encoding="utf-8"?>
@@ -1116,7 +578,7 @@
           <a:p>
             <a:r>
               <a:rPr lang="en-US" dirty="0"/>
-              <a:t>부식은 생각보다 큰 문제입니다. 전 세계가 매년 부식으로 잃는 비용은 약 2.5조 달러, 세계 GDP의 3.4%입니다. 환경 비용도 큽니다. 매년 생산되는 철강의 4분의 1에서 3분의 1이 부식으로 잃은 강재를 메우는 데 쓰이고, 이 강재를 다시 만드는 과정에서 전 세계 이산화탄소 배출의 1.6~3.4%가 나옵니다. 반대로 부식을 제때 찾아 관리하면 이 비용의 15~35%를 줄일 수 있습니다. 문제는 '제때 찾는 것'이 어렵다는 점입니다.</a:t>
+              <a:t>부식은 생각보다 큰 문제입니다. 전 세계가 매년 부식으로 잃는 비용은 약 2.5조 달러, 세계 GDP의 3.4%입니다. 국제 부식 학회인 AMPP가 2025년에도 공식적으로 인용하는 수치입니다. 환경 비용도 큽니다. 매년 생산되는 철강의 4분의 1에서 3분의 1이 부식으로 잃은 강재를 메우는 데 쓰이고, 이 강재를 다시 만드는 과정에서 전 세계 이산화탄소 배출의 1.6~3.4%가 나옵니다. 반대로 부식을 제때 찾아 관리하면 이 비용의 15~35%, 연간 3,750억에서 8,750억 달러를 줄일 수 있습니다. 문제는 '제때 찾는 것'이 어렵다는 점입니다.</a:t>
             </a:r>
           </a:p>
         </p:txBody>
@@ -1296,13 +758,13 @@
           <a:p>
             <a:r>
               <a:rPr lang="en-US" dirty="0"/>
-              <a:t>[약 30초]</a:t>
+              <a:t>[약 28초]</a:t>
             </a:r>
           </a:p>
           <a:p>
             <a:r>
               <a:rPr lang="en-US" dirty="0"/>
-              <a:t>특히 해양 구조물이 그렇습니다. 파도가 치는 비말대는 부식이 가장 빠른 곳인데, 로프 액세스나 잠수, ROV 없이는 볼 수가 없습니다. 미국 현장에서 들은 이야기는 일관됐습니다. 지금은 상태와 상관없이 모든 지점을 똑같이 돌고, 비용의 대부분은 검사 자체가 아니라 배를 빌리고 날씨를 기다리고 리프트를 빌리는 데서 나옵니다. 점검 주기는 규제로 정해져 있어 줄일 수 없습니다. 결국 문제는 그 주기 안에서 어디에 사람과 배를 먼저 보낼지입니다.</a:t>
+              <a:t>특히 해양 구조물이 그렇습니다. 파도가 치는 비말대는 부식이 가장 빠른 곳인데, 로프 액세스나 잠수, ROV 없이는 볼 수가 없습니다. 지금은 상태와 상관없이 모든 지점을 똑같이 돌고, 비용의 대부분은 검사 자체가 아니라 배를 빌리고 날씨를 기다리고 리프트를 빌리는 데서 나옵니다. 점검 주기는 규제로 정해져 있어 줄일 수 없습니다. 결국 문제는 그 주기 안에서 어디에 사람과 배를 먼저 보낼지입니다.</a:t>
             </a:r>
           </a:p>
         </p:txBody>
@@ -1482,13 +944,13 @@
           <a:p>
             <a:r>
               <a:rPr lang="en-US" dirty="0"/>
-              <a:t>[약 30초]</a:t>
+              <a:t>[약 35초]</a:t>
             </a:r>
           </a:p>
           <a:p>
             <a:r>
               <a:rPr lang="en-US" dirty="0"/>
-              <a:t>그래서 MLC는 이렇게 작동합니다. 드론이나 카메라로 접근이 어려운 구간을 먼저 찍습니다. 녹이 있는 부분만 자동으로 골라내고, 그 녹의 색으로 부식 속도 구간을 판정해 위험도를 높음, 중간, 낮음으로 매깁니다. 마지막으로 어느 지점부터 가까이 봐야 하는지 순서를 정한 리포트를 드립니다. 규제 주기는 그대로 지키면서, 사람과 배와 리프트를 위험한 곳에 먼저 보내는 겁니다.</a:t>
+              <a:t>그래서 MLC는 이렇게 작동합니다. 드론이나 카메라로 접근이 어려운 구간을 먼저 찍습니다. 녹이 있는 부분만 자동으로 골라내고, 그 녹의 색으로 부식 속도 구간을 판정해 위험도를 높음, 중간, 낮음으로 매깁니다. 마지막으로 구조물 사진 위에 위험한 지점부터 번호를 매긴 지도를 드립니다. 빨간 1번은 바로 점검하고, 파란 3번은 다음 주기로 미뤄도 되는 곳입니다. 규제 주기는 그대로 지키면서, 사람과 배와 리프트를 위험한 곳에 먼저 보내는 겁니다.</a:t>
             </a:r>
           </a:p>
         </p:txBody>
@@ -1575,13 +1037,13 @@
           <a:p>
             <a:r>
               <a:rPr lang="en-US" dirty="0"/>
-              <a:t>[약 30초]</a:t>
+              <a:t>[약 35초]</a:t>
             </a:r>
           </a:p>
           <a:p>
             <a:r>
               <a:rPr lang="en-US" dirty="0"/>
-              <a:t>핵심 기술은 실험실에서 검증했습니다. 탄소강을 240시간 촉진부식 시키며 아홉 시점에서 측정했더니, 녹의 색 좌표 b* 값이 커질수록 실제 부식 속도도 빨라졌고, 순위 상관계수는 0.88이었습니다. 위험도 세 구간은 서로 겹치지 않게 나뉩니다. 이 색 변화는 부식을 빠르게 만드는 다공성 녹 성분이 늘어나면서 생기기 때문에, 색과 속도가 함께 움직이는 물리적 근거도 있습니다. 이 결과는 SEM, XRD, 전기화학 등 여섯 가지 분석으로 교차 검증했습니다.</a:t>
+              <a:t>핵심 기술은 실험실에서 검증했습니다. 탄소강을 240시간 촉진부식 시키며 측정했습니다. 보시는 것처럼 표면의 녹 색이 변하면서 색 좌표 b* 값이 1.7에서 13.1로 커지고, 같은 기간 실제 부식 속도는 연 0.34mm에서 1.45mm로 약 4배 빨라졌습니다. 색과 부식 속도의 순위 상관계수는 0.88이고, 위험도 세 구간의 부식 속도는 서로 겹치지 않습니다. 이 색 변화는 부식을 빠르게 만드는 다공성 녹 성분이 늘어나면서 생기기 때문에, 색과 속도가 함께 움직이는 물리적 근거도 있습니다. 이 결과는 SEM, XRD, 전기화학 등 여섯 가지 분석으로 교차 검증했습니다.</a:t>
             </a:r>
           </a:p>
         </p:txBody>
@@ -1761,13 +1223,13 @@
           <a:p>
             <a:r>
               <a:rPr lang="en-US" dirty="0"/>
-              <a:t>[약 25초]</a:t>
+              <a:t>[약 30초]</a:t>
             </a:r>
           </a:p>
           <a:p>
             <a:r>
               <a:rPr lang="en-US" dirty="0"/>
-              <a:t>이 시장의 특징은 규제가 반복 수요를 만든다는 점입니다. 미국 해양 플랫폼은 매년 수상 육안 점검, 3~5년마다 수중 점검, 6~10년마다 정밀 점검을 해야 하고, 네 개 기관이 이를 겹쳐서 규제합니다. 미국에서 먼저 검증한 뒤 국내 해상풍력과 해양 플랜트로 넓힐 계획입니다.</a:t>
+              <a:t>이 시장은 규제가 반복 수요를 만듭니다. 미국 해양 플랫폼은 매년, 3~5년, 6~10년 주기로 점검이 의무입니다. 첫 타깃은 멕시코만의 유인 생산 플랫폼 371곳으로, 모두 매년 점검이 돌아오는 고객입니다. 인터뷰에서 확인한 구매 동기는 안전, 비용, 규제와 보험 대응 세 가지였습니다. 멕시코만 플랫폼에서 시작해 미드스트림 가스 압축 기지, 그리고 국내 해상풍력과 해양 플랜트로 넓혀 가겠습니다.</a:t>
             </a:r>
           </a:p>
         </p:txBody>
@@ -4059,7 +3521,7 @@
                 <a:ea typeface="맑은 고딕" pitchFamily="34" charset="-122"/>
                 <a:cs typeface="맑은 고딕" pitchFamily="34" charset="-120"/>
               </a:rPr>
-              <a:t>NACE IMPACT (2016)</a:t>
+              <a:t>NACE IMPACT (2016) · AMPP 2025 인용</a:t>
             </a:r>
             <a:endParaRPr lang="en-US" sz="1000" dirty="0"/>
           </a:p>
@@ -7279,13 +6741,12 @@
 
 <file path=ppt/slides/slide6.xml><?xml version="1.0" encoding="utf-8"?>
 <p:sld xmlns:a="http://schemas.openxmlformats.org/drawingml/2006/main" xmlns:r="http://schemas.openxmlformats.org/officeDocument/2006/relationships" xmlns:p="http://schemas.openxmlformats.org/presentationml/2006/main">
-  <p:cSld name="Slide 5">
+  <p:cSld name="Slide 1">
     <p:bg>
       <p:bgPr>
         <a:solidFill>
           <a:srgbClr val="FFFFFF"/>
         </a:solidFill>
-        <a:effectLst/>
       </p:bgPr>
     </p:bg>
     <p:spTree>
@@ -7323,11 +6784,11 @@
           <a:bodyPr wrap="square" lIns="0" tIns="0" rIns="0" bIns="0" rtlCol="0" anchor="t"/>
           <a:lstStyle/>
           <a:p>
-            <a:pPr marL="0" indent="0">
-              <a:buNone/>
-            </a:pPr>
-            <a:r>
-              <a:rPr lang="en-US" sz="1200" b="1" kern="0" spc="100" dirty="0">
+            <a:pPr indent="0" marL="0">
+              <a:buNone/>
+            </a:pPr>
+            <a:r>
+              <a:rPr lang="en-US" sz="1200" b="1" spc="100" kern="0" dirty="0">
                 <a:solidFill>
                   <a:srgbClr val="B5501F"/>
                 </a:solidFill>
@@ -7362,7 +6823,7 @@
           <a:bodyPr wrap="square" lIns="0" tIns="0" rIns="0" bIns="0" rtlCol="0" anchor="ctr"/>
           <a:lstStyle/>
           <a:p>
-            <a:pPr marL="0" indent="0">
+            <a:pPr indent="0" marL="0">
               <a:buNone/>
             </a:pPr>
             <a:r>
@@ -7401,7 +6862,7 @@
           <a:bodyPr wrap="square" lIns="0" tIns="0" rIns="0" bIns="0" rtlCol="0" anchor="t"/>
           <a:lstStyle/>
           <a:p>
-            <a:pPr marL="0" indent="0">
+            <a:pPr indent="0" marL="0">
               <a:buNone/>
             </a:pPr>
             <a:r>
@@ -7413,29 +6874,7 @@
                 <a:ea typeface="맑은 고딕" pitchFamily="34" charset="-122"/>
                 <a:cs typeface="맑은 고딕" pitchFamily="34" charset="-120"/>
               </a:rPr>
-              <a:t>MLC  ·  </a:t>
-            </a:r>
-            <a:r>
-              <a:rPr lang="en-US" sz="900" dirty="0" err="1">
-                <a:solidFill>
-                  <a:srgbClr val="A3A7AD"/>
-                </a:solidFill>
-                <a:latin typeface="맑은 고딕" pitchFamily="34" charset="0"/>
-                <a:ea typeface="맑은 고딕" pitchFamily="34" charset="-122"/>
-                <a:cs typeface="맑은 고딕" pitchFamily="34" charset="-120"/>
-              </a:rPr>
-              <a:t>제주</a:t>
-            </a:r>
-            <a:r>
-              <a:rPr lang="en-US" sz="900" dirty="0">
-                <a:solidFill>
-                  <a:srgbClr val="A3A7AD"/>
-                </a:solidFill>
-                <a:latin typeface="맑은 고딕" pitchFamily="34" charset="0"/>
-                <a:ea typeface="맑은 고딕" pitchFamily="34" charset="-122"/>
-                <a:cs typeface="맑은 고딕" pitchFamily="34" charset="-120"/>
-              </a:rPr>
-              <a:t> A-STREAM 2026</a:t>
+              <a:t>MLC  ·  제주 A-STREAM 2026</a:t>
             </a:r>
             <a:endParaRPr lang="en-US" sz="900" dirty="0"/>
           </a:p>
@@ -7462,7 +6901,7 @@
           <a:bodyPr wrap="square" lIns="0" tIns="0" rIns="0" bIns="0" rtlCol="0" anchor="t"/>
           <a:lstStyle/>
           <a:p>
-            <a:pPr marL="0" indent="0" algn="r">
+            <a:pPr algn="r" indent="0" marL="0">
               <a:buNone/>
             </a:pPr>
             <a:r>
@@ -7482,14 +6921,14 @@
       </p:sp>
       <p:pic>
         <p:nvPicPr>
-          <p:cNvPr id="6" name="Image 0" descr="/home/user/PPT/src/img/photo_15.png"/>
+          <p:cNvPr id="6" name="Image 0" descr="/home/user/PPT/src/img/photo_15.png">    </p:cNvPr>
           <p:cNvPicPr>
             <a:picLocks noChangeAspect="1"/>
           </p:cNvPicPr>
           <p:nvPr/>
         </p:nvPicPr>
         <p:blipFill>
-          <a:blip r:embed="rId3"/>
+          <a:blip r:embed="rId1"/>
           <a:stretch>
             <a:fillRect/>
           </a:stretch>
@@ -7550,7 +6989,7 @@
           <a:bodyPr wrap="square" lIns="0" tIns="0" rIns="0" bIns="0" rtlCol="0" anchor="ctr"/>
           <a:lstStyle/>
           <a:p>
-            <a:pPr marL="0" indent="0" algn="ctr">
+            <a:pPr algn="ctr" indent="0" marL="0">
               <a:buNone/>
             </a:pPr>
             <a:r>
@@ -7589,7 +7028,7 @@
           <a:bodyPr wrap="square" lIns="0" tIns="0" rIns="0" bIns="0" rtlCol="0" anchor="t"/>
           <a:lstStyle/>
           <a:p>
-            <a:pPr marL="0" indent="0">
+            <a:pPr indent="0" marL="0">
               <a:buNone/>
             </a:pPr>
             <a:r>
@@ -7628,7 +7067,7 @@
           <a:bodyPr wrap="square" lIns="0" tIns="0" rIns="0" bIns="0" rtlCol="0" anchor="t"/>
           <a:lstStyle/>
           <a:p>
-            <a:pPr marL="0" indent="0">
+            <a:pPr indent="0" marL="0">
               <a:buNone/>
             </a:pPr>
             <a:r>
@@ -7645,7 +7084,7 @@
             <a:endParaRPr lang="en-US" sz="1250" dirty="0"/>
           </a:p>
           <a:p>
-            <a:pPr marL="0" indent="0">
+            <a:pPr indent="0" marL="0">
               <a:buNone/>
             </a:pPr>
             <a:r>
@@ -7665,14 +7104,14 @@
       </p:sp>
       <p:pic>
         <p:nvPicPr>
-          <p:cNvPr id="11" name="Image 1" descr="preencoded.png"/>
+          <p:cNvPr id="11" name="Image 1" descr="preencoded.png">    </p:cNvPr>
           <p:cNvPicPr>
             <a:picLocks noChangeAspect="1"/>
           </p:cNvPicPr>
           <p:nvPr/>
         </p:nvPicPr>
         <p:blipFill>
-          <a:blip r:embed="rId4"/>
+          <a:blip r:embed="rId2"/>
           <a:stretch>
             <a:fillRect/>
           </a:stretch>
@@ -7689,14 +7128,14 @@
       </p:pic>
       <p:pic>
         <p:nvPicPr>
-          <p:cNvPr id="12" name="Image 2" descr="/home/user/PPT/src/img/mask_15.png"/>
+          <p:cNvPr id="12" name="Image 2" descr="/home/user/PPT/src/img/mask_15.png">    </p:cNvPr>
           <p:cNvPicPr>
             <a:picLocks noChangeAspect="1"/>
           </p:cNvPicPr>
           <p:nvPr/>
         </p:nvPicPr>
         <p:blipFill>
-          <a:blip r:embed="rId5"/>
+          <a:blip r:embed="rId3"/>
           <a:stretch>
             <a:fillRect/>
           </a:stretch>
@@ -7757,7 +7196,7 @@
           <a:bodyPr wrap="square" lIns="0" tIns="0" rIns="0" bIns="0" rtlCol="0" anchor="ctr"/>
           <a:lstStyle/>
           <a:p>
-            <a:pPr marL="0" indent="0" algn="ctr">
+            <a:pPr algn="ctr" indent="0" marL="0">
               <a:buNone/>
             </a:pPr>
             <a:r>
@@ -7796,7 +7235,7 @@
           <a:bodyPr wrap="square" lIns="0" tIns="0" rIns="0" bIns="0" rtlCol="0" anchor="t"/>
           <a:lstStyle/>
           <a:p>
-            <a:pPr marL="0" indent="0">
+            <a:pPr indent="0" marL="0">
               <a:buNone/>
             </a:pPr>
             <a:r>
@@ -7835,7 +7274,7 @@
           <a:bodyPr wrap="square" lIns="0" tIns="0" rIns="0" bIns="0" rtlCol="0" anchor="t"/>
           <a:lstStyle/>
           <a:p>
-            <a:pPr marL="0" indent="0">
+            <a:pPr indent="0" marL="0">
               <a:buNone/>
             </a:pPr>
             <a:r>
@@ -7852,7 +7291,7 @@
             <a:endParaRPr lang="en-US" sz="1250" dirty="0"/>
           </a:p>
           <a:p>
-            <a:pPr marL="0" indent="0">
+            <a:pPr indent="0" marL="0">
               <a:buNone/>
             </a:pPr>
             <a:r>
@@ -7872,7 +7311,7 @@
       </p:sp>
       <p:pic>
         <p:nvPicPr>
-          <p:cNvPr id="17" name="Image 3" descr="preencoded.png"/>
+          <p:cNvPr id="17" name="Image 3" descr="preencoded.png">    </p:cNvPr>
           <p:cNvPicPr>
             <a:picLocks noChangeAspect="1"/>
           </p:cNvPicPr>
@@ -7940,7 +7379,7 @@
           <a:bodyPr wrap="square" lIns="0" tIns="0" rIns="0" bIns="0" rtlCol="0" anchor="ctr"/>
           <a:lstStyle/>
           <a:p>
-            <a:pPr marL="0" indent="0" algn="ctr">
+            <a:pPr algn="ctr" indent="0" marL="0">
               <a:buNone/>
             </a:pPr>
             <a:r>
@@ -8006,7 +7445,7 @@
           <a:bodyPr wrap="square" lIns="0" tIns="0" rIns="0" bIns="0" rtlCol="0" anchor="ctr"/>
           <a:lstStyle/>
           <a:p>
-            <a:pPr marL="0" indent="0" algn="ctr">
+            <a:pPr algn="ctr" indent="0" marL="0">
               <a:buNone/>
             </a:pPr>
             <a:r>
@@ -8070,7 +7509,7 @@
           <a:bodyPr wrap="square" lIns="0" tIns="0" rIns="0" bIns="0" rtlCol="0" anchor="ctr"/>
           <a:lstStyle/>
           <a:p>
-            <a:pPr marL="0" indent="0" algn="ctr">
+            <a:pPr algn="ctr" indent="0" marL="0">
               <a:buNone/>
             </a:pPr>
             <a:r>
@@ -8109,7 +7548,7 @@
           <a:bodyPr wrap="square" lIns="0" tIns="0" rIns="0" bIns="0" rtlCol="0" anchor="t"/>
           <a:lstStyle/>
           <a:p>
-            <a:pPr marL="0" indent="0">
+            <a:pPr indent="0" marL="0">
               <a:buNone/>
             </a:pPr>
             <a:r>
@@ -8148,7 +7587,7 @@
           <a:bodyPr wrap="square" lIns="0" tIns="0" rIns="0" bIns="0" rtlCol="0" anchor="t"/>
           <a:lstStyle/>
           <a:p>
-            <a:pPr marL="0" indent="0">
+            <a:pPr indent="0" marL="0">
               <a:buNone/>
             </a:pPr>
             <a:r>
@@ -8165,7 +7604,7 @@
             <a:endParaRPr lang="en-US" sz="1250" dirty="0"/>
           </a:p>
           <a:p>
-            <a:pPr marL="0" indent="0">
+            <a:pPr indent="0" marL="0">
               <a:buNone/>
             </a:pPr>
             <a:r>
@@ -8185,14 +7624,14 @@
       </p:sp>
       <p:pic>
         <p:nvPicPr>
-          <p:cNvPr id="26" name="Image 4" descr="preencoded.png"/>
+          <p:cNvPr id="26" name="Image 4" descr="preencoded.png">    </p:cNvPr>
           <p:cNvPicPr>
             <a:picLocks noChangeAspect="1"/>
           </p:cNvPicPr>
           <p:nvPr/>
         </p:nvPicPr>
         <p:blipFill>
-          <a:blip r:embed="rId4"/>
+          <a:blip r:embed="rId5"/>
           <a:stretch>
             <a:fillRect/>
           </a:stretch>
@@ -8207,28 +7646,49 @@
           </a:prstGeom>
         </p:spPr>
       </p:pic>
-      <p:sp>
-        <p:nvSpPr>
-          <p:cNvPr id="27" name="Shape 20"/>
-          <p:cNvSpPr/>
-          <p:nvPr/>
-        </p:nvSpPr>
+      <p:pic>
+        <p:nvPicPr>
+          <p:cNvPr id="27" name="Image 5" descr="/home/user/PPT/src/img/offshore_legs.png">    </p:cNvPr>
+          <p:cNvPicPr>
+            <a:picLocks noChangeAspect="1"/>
+          </p:cNvPicPr>
+          <p:nvPr/>
+        </p:nvPicPr>
+        <p:blipFill>
+          <a:blip r:embed="rId6"/>
+          <a:srcRect l="0" r="0" t="0" b="0"/>
+          <a:stretch/>
+        </p:blipFill>
         <p:spPr>
           <a:xfrm>
             <a:off x="9311335" y="1463040"/>
             <a:ext cx="2331720" cy="2331720"/>
           </a:xfrm>
-          <a:prstGeom prst="roundRect">
-            <a:avLst>
-              <a:gd name="adj" fmla="val 3137"/>
-            </a:avLst>
+          <a:prstGeom prst="rect">
+            <a:avLst/>
+          </a:prstGeom>
+        </p:spPr>
+      </p:pic>
+      <p:sp>
+        <p:nvSpPr>
+          <p:cNvPr id="28" name="Shape 20"/>
+          <p:cNvSpPr/>
+          <p:nvPr/>
+        </p:nvSpPr>
+        <p:spPr>
+          <a:xfrm>
+            <a:off x="9758020" y="2725826"/>
+            <a:ext cx="365760" cy="365760"/>
+          </a:xfrm>
+          <a:prstGeom prst="ellipse">
+            <a:avLst/>
           </a:prstGeom>
           <a:solidFill>
-            <a:srgbClr val="F3F4F6"/>
+            <a:srgbClr val="B23A2E"/>
           </a:solidFill>
-          <a:ln w="6350">
+          <a:ln w="25400">
             <a:solidFill>
-              <a:srgbClr val="F3F4F6"/>
+              <a:srgbClr val="FFFFFF"/>
             </a:solidFill>
             <a:prstDash val="solid"/>
           </a:ln>
@@ -8236,22 +7696,63 @@
       </p:sp>
       <p:sp>
         <p:nvSpPr>
-          <p:cNvPr id="28" name="Shape 21"/>
+          <p:cNvPr id="29" name="Text 21"/>
+          <p:cNvSpPr txBox="1"/>
+          <p:nvPr/>
+        </p:nvSpPr>
+        <p:spPr>
+          <a:xfrm>
+            <a:off x="9758020" y="2725826"/>
+            <a:ext cx="365760" cy="365760"/>
+          </a:xfrm>
+          <a:prstGeom prst="rect">
+            <a:avLst/>
+          </a:prstGeom>
+          <a:noFill/>
+          <a:ln/>
+        </p:spPr>
+        <p:txBody>
+          <a:bodyPr wrap="square" lIns="0" tIns="0" rIns="0" bIns="0" rtlCol="0" anchor="ctr"/>
+          <a:lstStyle/>
+          <a:p>
+            <a:pPr algn="ctr" indent="0" marL="0">
+              <a:buNone/>
+            </a:pPr>
+            <a:r>
+              <a:rPr lang="en-US" sz="1400" b="1" dirty="0">
+                <a:solidFill>
+                  <a:srgbClr val="FFFFFF"/>
+                </a:solidFill>
+                <a:latin typeface="맑은 고딕" pitchFamily="34" charset="0"/>
+                <a:ea typeface="맑은 고딕" pitchFamily="34" charset="-122"/>
+                <a:cs typeface="맑은 고딕" pitchFamily="34" charset="-120"/>
+              </a:rPr>
+              <a:t>1</a:t>
+            </a:r>
+            <a:endParaRPr lang="en-US" sz="1400" dirty="0"/>
+          </a:p>
+        </p:txBody>
+      </p:sp>
+      <p:sp>
+        <p:nvSpPr>
+          <p:cNvPr id="30" name="Shape 22"/>
           <p:cNvSpPr/>
           <p:nvPr/>
         </p:nvSpPr>
         <p:spPr>
           <a:xfrm>
-            <a:off x="9475927" y="1691640"/>
-            <a:ext cx="2002536" cy="566928"/>
+            <a:off x="10160356" y="2780690"/>
+            <a:ext cx="854964" cy="256032"/>
           </a:xfrm>
           <a:prstGeom prst="roundRect">
             <a:avLst>
-              <a:gd name="adj" fmla="val 9677"/>
+              <a:gd name="adj" fmla="val 50000"/>
             </a:avLst>
           </a:prstGeom>
           <a:solidFill>
-            <a:srgbClr val="B23A2E"/>
+            <a:srgbClr val="FFFFFF">
+              <a:alpha val="92000"/>
+            </a:srgbClr>
           </a:solidFill>
           <a:ln w="12700">
             <a:solidFill>
@@ -8263,14 +7764,14 @@
       </p:sp>
       <p:sp>
         <p:nvSpPr>
-          <p:cNvPr id="29" name="Text 22"/>
-          <p:cNvSpPr txBox="1"/>
-          <p:nvPr/>
-        </p:nvSpPr>
-        <p:spPr>
-          <a:xfrm>
-            <a:off x="9603943" y="1691640"/>
-            <a:ext cx="1783080" cy="566928"/>
+          <p:cNvPr id="31" name="Text 23"/>
+          <p:cNvSpPr txBox="1"/>
+          <p:nvPr/>
+        </p:nvSpPr>
+        <p:spPr>
+          <a:xfrm>
+            <a:off x="10160356" y="2780690"/>
+            <a:ext cx="854964" cy="256032"/>
           </a:xfrm>
           <a:prstGeom prst="rect">
             <a:avLst/>
@@ -8282,11 +7783,75 @@
           <a:bodyPr wrap="square" lIns="0" tIns="0" rIns="0" bIns="0" rtlCol="0" anchor="ctr"/>
           <a:lstStyle/>
           <a:p>
-            <a:pPr marL="0" indent="0">
-              <a:buNone/>
-            </a:pPr>
-            <a:r>
-              <a:rPr lang="en-US" sz="1300" b="1" dirty="0">
+            <a:pPr algn="ctr" indent="0" marL="0">
+              <a:buNone/>
+            </a:pPr>
+            <a:r>
+              <a:rPr lang="en-US" sz="950" b="1" dirty="0">
+                <a:solidFill>
+                  <a:srgbClr val="B23A2E"/>
+                </a:solidFill>
+                <a:latin typeface="맑은 고딕" pitchFamily="34" charset="0"/>
+                <a:ea typeface="맑은 고딕" pitchFamily="34" charset="-122"/>
+                <a:cs typeface="맑은 고딕" pitchFamily="34" charset="-120"/>
+              </a:rPr>
+              <a:t>높음 · 즉시</a:t>
+            </a:r>
+            <a:endParaRPr lang="en-US" sz="950" dirty="0"/>
+          </a:p>
+        </p:txBody>
+      </p:sp>
+      <p:sp>
+        <p:nvSpPr>
+          <p:cNvPr id="32" name="Shape 24"/>
+          <p:cNvSpPr/>
+          <p:nvPr/>
+        </p:nvSpPr>
+        <p:spPr>
+          <a:xfrm>
+            <a:off x="10947197" y="2259482"/>
+            <a:ext cx="365760" cy="365760"/>
+          </a:xfrm>
+          <a:prstGeom prst="ellipse">
+            <a:avLst/>
+          </a:prstGeom>
+          <a:solidFill>
+            <a:srgbClr val="3C8D5A"/>
+          </a:solidFill>
+          <a:ln w="25400">
+            <a:solidFill>
+              <a:srgbClr val="FFFFFF"/>
+            </a:solidFill>
+            <a:prstDash val="solid"/>
+          </a:ln>
+        </p:spPr>
+      </p:sp>
+      <p:sp>
+        <p:nvSpPr>
+          <p:cNvPr id="33" name="Text 25"/>
+          <p:cNvSpPr txBox="1"/>
+          <p:nvPr/>
+        </p:nvSpPr>
+        <p:spPr>
+          <a:xfrm>
+            <a:off x="10947197" y="2259482"/>
+            <a:ext cx="365760" cy="365760"/>
+          </a:xfrm>
+          <a:prstGeom prst="rect">
+            <a:avLst/>
+          </a:prstGeom>
+          <a:noFill/>
+          <a:ln/>
+        </p:spPr>
+        <p:txBody>
+          <a:bodyPr wrap="square" lIns="0" tIns="0" rIns="0" bIns="0" rtlCol="0" anchor="ctr"/>
+          <a:lstStyle/>
+          <a:p>
+            <a:pPr algn="ctr" indent="0" marL="0">
+              <a:buNone/>
+            </a:pPr>
+            <a:r>
+              <a:rPr lang="en-US" sz="1400" b="1" dirty="0">
                 <a:solidFill>
                   <a:srgbClr val="FFFFFF"/>
                 </a:solidFill>
@@ -8294,47 +7859,32 @@
                 <a:ea typeface="맑은 고딕" pitchFamily="34" charset="-122"/>
                 <a:cs typeface="맑은 고딕" pitchFamily="34" charset="-120"/>
               </a:rPr>
-              <a:t>1. A-07  높음</a:t>
-            </a:r>
-            <a:endParaRPr lang="en-US" sz="1300" dirty="0"/>
-          </a:p>
-          <a:p>
-            <a:pPr marL="0" indent="0">
-              <a:buNone/>
-            </a:pPr>
-            <a:r>
-              <a:rPr lang="en-US" sz="1050" dirty="0">
-                <a:solidFill>
-                  <a:srgbClr val="FFFFFF"/>
-                </a:solidFill>
-                <a:latin typeface="맑은 고딕" pitchFamily="34" charset="0"/>
-                <a:ea typeface="맑은 고딕" pitchFamily="34" charset="-122"/>
-                <a:cs typeface="맑은 고딕" pitchFamily="34" charset="-120"/>
-              </a:rPr>
-              <a:t>이번 주 점검</a:t>
-            </a:r>
-            <a:endParaRPr lang="en-US" sz="1300" dirty="0"/>
-          </a:p>
-        </p:txBody>
-      </p:sp>
-      <p:sp>
-        <p:nvSpPr>
-          <p:cNvPr id="30" name="Shape 23"/>
+              <a:t>2</a:t>
+            </a:r>
+            <a:endParaRPr lang="en-US" sz="1400" dirty="0"/>
+          </a:p>
+        </p:txBody>
+      </p:sp>
+      <p:sp>
+        <p:nvSpPr>
+          <p:cNvPr id="34" name="Shape 26"/>
           <p:cNvSpPr/>
           <p:nvPr/>
         </p:nvSpPr>
         <p:spPr>
           <a:xfrm>
-            <a:off x="9475927" y="2377440"/>
-            <a:ext cx="2002536" cy="566928"/>
+            <a:off x="9767621" y="2314346"/>
+            <a:ext cx="1143000" cy="256032"/>
           </a:xfrm>
           <a:prstGeom prst="roundRect">
             <a:avLst>
-              <a:gd name="adj" fmla="val 9677"/>
+              <a:gd name="adj" fmla="val 50000"/>
             </a:avLst>
           </a:prstGeom>
           <a:solidFill>
-            <a:srgbClr val="FFFFFF"/>
+            <a:srgbClr val="FFFFFF">
+              <a:alpha val="92000"/>
+            </a:srgbClr>
           </a:solidFill>
           <a:ln w="12700">
             <a:solidFill>
@@ -8346,14 +7896,14 @@
       </p:sp>
       <p:sp>
         <p:nvSpPr>
-          <p:cNvPr id="31" name="Text 24"/>
-          <p:cNvSpPr txBox="1"/>
-          <p:nvPr/>
-        </p:nvSpPr>
-        <p:spPr>
-          <a:xfrm>
-            <a:off x="9603943" y="2377440"/>
-            <a:ext cx="1783080" cy="566928"/>
+          <p:cNvPr id="35" name="Text 27"/>
+          <p:cNvSpPr txBox="1"/>
+          <p:nvPr/>
+        </p:nvSpPr>
+        <p:spPr>
+          <a:xfrm>
+            <a:off x="9767621" y="2314346"/>
+            <a:ext cx="1143000" cy="256032"/>
           </a:xfrm>
           <a:prstGeom prst="rect">
             <a:avLst/>
@@ -8365,22 +7915,11 @@
           <a:bodyPr wrap="square" lIns="0" tIns="0" rIns="0" bIns="0" rtlCol="0" anchor="ctr"/>
           <a:lstStyle/>
           <a:p>
-            <a:pPr marL="0" indent="0">
-              <a:buNone/>
-            </a:pPr>
-            <a:r>
-              <a:rPr lang="en-US" sz="1300" b="1" dirty="0">
-                <a:solidFill>
-                  <a:srgbClr val="2B2D31"/>
-                </a:solidFill>
-                <a:latin typeface="맑은 고딕" pitchFamily="34" charset="0"/>
-                <a:ea typeface="맑은 고딕" pitchFamily="34" charset="-122"/>
-                <a:cs typeface="맑은 고딕" pitchFamily="34" charset="-120"/>
-              </a:rPr>
-              <a:t>2. C-12  </a:t>
-            </a:r>
-            <a:r>
-              <a:rPr lang="en-US" sz="1300" b="1" dirty="0">
+            <a:pPr algn="ctr" indent="0" marL="0">
+              <a:buNone/>
+            </a:pPr>
+            <a:r>
+              <a:rPr lang="en-US" sz="950" b="1" dirty="0">
                 <a:solidFill>
                   <a:srgbClr val="3C8D5A"/>
                 </a:solidFill>
@@ -8388,47 +7927,96 @@
                 <a:ea typeface="맑은 고딕" pitchFamily="34" charset="-122"/>
                 <a:cs typeface="맑은 고딕" pitchFamily="34" charset="-120"/>
               </a:rPr>
-              <a:t>중간</a:t>
-            </a:r>
-            <a:endParaRPr lang="en-US" sz="1300" dirty="0"/>
-          </a:p>
-          <a:p>
-            <a:pPr marL="0" indent="0">
-              <a:buNone/>
-            </a:pPr>
-            <a:r>
-              <a:rPr lang="en-US" sz="1050" dirty="0">
-                <a:solidFill>
-                  <a:srgbClr val="6B6F76"/>
-                </a:solidFill>
-                <a:latin typeface="맑은 고딕" pitchFamily="34" charset="0"/>
-                <a:ea typeface="맑은 고딕" pitchFamily="34" charset="-122"/>
-                <a:cs typeface="맑은 고딕" pitchFamily="34" charset="-120"/>
-              </a:rPr>
-              <a:t>이번 주기 내</a:t>
-            </a:r>
-            <a:endParaRPr lang="en-US" sz="1300" dirty="0"/>
-          </a:p>
-        </p:txBody>
-      </p:sp>
-      <p:sp>
-        <p:nvSpPr>
-          <p:cNvPr id="32" name="Shape 25"/>
+              <a:t>중간 · 이번 주기</a:t>
+            </a:r>
+            <a:endParaRPr lang="en-US" sz="950" dirty="0"/>
+          </a:p>
+        </p:txBody>
+      </p:sp>
+      <p:sp>
+        <p:nvSpPr>
+          <p:cNvPr id="36" name="Shape 28"/>
           <p:cNvSpPr/>
           <p:nvPr/>
         </p:nvSpPr>
         <p:spPr>
           <a:xfrm>
-            <a:off x="9475927" y="3063240"/>
-            <a:ext cx="2002536" cy="566928"/>
+            <a:off x="10061143" y="1653235"/>
+            <a:ext cx="365760" cy="365760"/>
+          </a:xfrm>
+          <a:prstGeom prst="ellipse">
+            <a:avLst/>
+          </a:prstGeom>
+          <a:solidFill>
+            <a:srgbClr val="3A6EA5"/>
+          </a:solidFill>
+          <a:ln w="25400">
+            <a:solidFill>
+              <a:srgbClr val="FFFFFF"/>
+            </a:solidFill>
+            <a:prstDash val="solid"/>
+          </a:ln>
+        </p:spPr>
+      </p:sp>
+      <p:sp>
+        <p:nvSpPr>
+          <p:cNvPr id="37" name="Text 29"/>
+          <p:cNvSpPr txBox="1"/>
+          <p:nvPr/>
+        </p:nvSpPr>
+        <p:spPr>
+          <a:xfrm>
+            <a:off x="10061143" y="1653235"/>
+            <a:ext cx="365760" cy="365760"/>
+          </a:xfrm>
+          <a:prstGeom prst="rect">
+            <a:avLst/>
+          </a:prstGeom>
+          <a:noFill/>
+          <a:ln/>
+        </p:spPr>
+        <p:txBody>
+          <a:bodyPr wrap="square" lIns="0" tIns="0" rIns="0" bIns="0" rtlCol="0" anchor="ctr"/>
+          <a:lstStyle/>
+          <a:p>
+            <a:pPr algn="ctr" indent="0" marL="0">
+              <a:buNone/>
+            </a:pPr>
+            <a:r>
+              <a:rPr lang="en-US" sz="1400" b="1" dirty="0">
+                <a:solidFill>
+                  <a:srgbClr val="FFFFFF"/>
+                </a:solidFill>
+                <a:latin typeface="맑은 고딕" pitchFamily="34" charset="0"/>
+                <a:ea typeface="맑은 고딕" pitchFamily="34" charset="-122"/>
+                <a:cs typeface="맑은 고딕" pitchFamily="34" charset="-120"/>
+              </a:rPr>
+              <a:t>3</a:t>
+            </a:r>
+            <a:endParaRPr lang="en-US" sz="1400" dirty="0"/>
+          </a:p>
+        </p:txBody>
+      </p:sp>
+      <p:sp>
+        <p:nvSpPr>
+          <p:cNvPr id="38" name="Shape 30"/>
+          <p:cNvSpPr/>
+          <p:nvPr/>
+        </p:nvSpPr>
+        <p:spPr>
+          <a:xfrm>
+            <a:off x="10463479" y="1708099"/>
+            <a:ext cx="1143000" cy="256032"/>
           </a:xfrm>
           <a:prstGeom prst="roundRect">
             <a:avLst>
-              <a:gd name="adj" fmla="val 9677"/>
+              <a:gd name="adj" fmla="val 50000"/>
             </a:avLst>
           </a:prstGeom>
           <a:solidFill>
-            <a:srgbClr val="FFFFFF"/>
+            <a:srgbClr val="FFFFFF">
+              <a:alpha val="92000"/>
+            </a:srgbClr>
           </a:solidFill>
           <a:ln w="12700">
             <a:solidFill>
@@ -8440,14 +8028,14 @@
       </p:sp>
       <p:sp>
         <p:nvSpPr>
-          <p:cNvPr id="33" name="Text 26"/>
-          <p:cNvSpPr txBox="1"/>
-          <p:nvPr/>
-        </p:nvSpPr>
-        <p:spPr>
-          <a:xfrm>
-            <a:off x="9603943" y="3063240"/>
-            <a:ext cx="1783080" cy="566928"/>
+          <p:cNvPr id="39" name="Text 31"/>
+          <p:cNvSpPr txBox="1"/>
+          <p:nvPr/>
+        </p:nvSpPr>
+        <p:spPr>
+          <a:xfrm>
+            <a:off x="10463479" y="1708099"/>
+            <a:ext cx="1143000" cy="256032"/>
           </a:xfrm>
           <a:prstGeom prst="rect">
             <a:avLst/>
@@ -8459,22 +8047,11 @@
           <a:bodyPr wrap="square" lIns="0" tIns="0" rIns="0" bIns="0" rtlCol="0" anchor="ctr"/>
           <a:lstStyle/>
           <a:p>
-            <a:pPr marL="0" indent="0">
-              <a:buNone/>
-            </a:pPr>
-            <a:r>
-              <a:rPr lang="en-US" sz="1300" b="1" dirty="0">
-                <a:solidFill>
-                  <a:srgbClr val="2B2D31"/>
-                </a:solidFill>
-                <a:latin typeface="맑은 고딕" pitchFamily="34" charset="0"/>
-                <a:ea typeface="맑은 고딕" pitchFamily="34" charset="-122"/>
-                <a:cs typeface="맑은 고딕" pitchFamily="34" charset="-120"/>
-              </a:rPr>
-              <a:t>3. B-03  </a:t>
-            </a:r>
-            <a:r>
-              <a:rPr lang="en-US" sz="1300" b="1" dirty="0">
+            <a:pPr algn="ctr" indent="0" marL="0">
+              <a:buNone/>
+            </a:pPr>
+            <a:r>
+              <a:rPr lang="en-US" sz="950" b="1" dirty="0">
                 <a:solidFill>
                   <a:srgbClr val="3A6EA5"/>
                 </a:solidFill>
@@ -8482,32 +8059,15 @@
                 <a:ea typeface="맑은 고딕" pitchFamily="34" charset="-122"/>
                 <a:cs typeface="맑은 고딕" pitchFamily="34" charset="-120"/>
               </a:rPr>
-              <a:t>낮음</a:t>
-            </a:r>
-            <a:endParaRPr lang="en-US" sz="1300" dirty="0"/>
-          </a:p>
-          <a:p>
-            <a:pPr marL="0" indent="0">
-              <a:buNone/>
-            </a:pPr>
-            <a:r>
-              <a:rPr lang="en-US" sz="1050" dirty="0">
-                <a:solidFill>
-                  <a:srgbClr val="6B6F76"/>
-                </a:solidFill>
-                <a:latin typeface="맑은 고딕" pitchFamily="34" charset="0"/>
-                <a:ea typeface="맑은 고딕" pitchFamily="34" charset="-122"/>
-                <a:cs typeface="맑은 고딕" pitchFamily="34" charset="-120"/>
-              </a:rPr>
-              <a:t>다음 주기</a:t>
-            </a:r>
-            <a:endParaRPr lang="en-US" sz="1300" dirty="0"/>
-          </a:p>
-        </p:txBody>
-      </p:sp>
-      <p:sp>
-        <p:nvSpPr>
-          <p:cNvPr id="34" name="Shape 27"/>
+              <a:t>낮음 · 다음 주기</a:t>
+            </a:r>
+            <a:endParaRPr lang="en-US" sz="950" dirty="0"/>
+          </a:p>
+        </p:txBody>
+      </p:sp>
+      <p:sp>
+        <p:nvSpPr>
+          <p:cNvPr id="40" name="Shape 32"/>
           <p:cNvSpPr/>
           <p:nvPr/>
         </p:nvSpPr>
@@ -8532,7 +8092,7 @@
       </p:sp>
       <p:sp>
         <p:nvSpPr>
-          <p:cNvPr id="35" name="Text 28"/>
+          <p:cNvPr id="41" name="Text 33"/>
           <p:cNvSpPr txBox="1"/>
           <p:nvPr/>
         </p:nvSpPr>
@@ -8551,7 +8111,7 @@
           <a:bodyPr wrap="square" lIns="0" tIns="0" rIns="0" bIns="0" rtlCol="0" anchor="ctr"/>
           <a:lstStyle/>
           <a:p>
-            <a:pPr marL="0" indent="0" algn="ctr">
+            <a:pPr algn="ctr" indent="0" marL="0">
               <a:buNone/>
             </a:pPr>
             <a:r>
@@ -8571,7 +8131,7 @@
       </p:sp>
       <p:sp>
         <p:nvSpPr>
-          <p:cNvPr id="36" name="Text 29"/>
+          <p:cNvPr id="42" name="Text 34"/>
           <p:cNvSpPr txBox="1"/>
           <p:nvPr/>
         </p:nvSpPr>
@@ -8590,7 +8150,7 @@
           <a:bodyPr wrap="square" lIns="0" tIns="0" rIns="0" bIns="0" rtlCol="0" anchor="t"/>
           <a:lstStyle/>
           <a:p>
-            <a:pPr marL="0" indent="0">
+            <a:pPr indent="0" marL="0">
               <a:buNone/>
             </a:pPr>
             <a:r>
@@ -8602,7 +8162,7 @@
                 <a:ea typeface="맑은 고딕" pitchFamily="34" charset="-122"/>
                 <a:cs typeface="맑은 고딕" pitchFamily="34" charset="-120"/>
               </a:rPr>
-              <a:t>점검 우선순위 리포트</a:t>
+              <a:t>점검 우선순위 지도</a:t>
             </a:r>
             <a:endParaRPr lang="en-US" sz="1600" dirty="0"/>
           </a:p>
@@ -8610,7 +8170,7 @@
       </p:sp>
       <p:sp>
         <p:nvSpPr>
-          <p:cNvPr id="37" name="Text 30"/>
+          <p:cNvPr id="43" name="Text 35"/>
           <p:cNvSpPr txBox="1"/>
           <p:nvPr/>
         </p:nvSpPr>
@@ -8629,7 +8189,7 @@
           <a:bodyPr wrap="square" lIns="0" tIns="0" rIns="0" bIns="0" rtlCol="0" anchor="t"/>
           <a:lstStyle/>
           <a:p>
-            <a:pPr marL="0" indent="0">
+            <a:pPr indent="0" marL="0">
               <a:buNone/>
             </a:pPr>
             <a:r>
@@ -8641,12 +8201,12 @@
                 <a:ea typeface="맑은 고딕" pitchFamily="34" charset="-122"/>
                 <a:cs typeface="맑은 고딕" pitchFamily="34" charset="-120"/>
               </a:rPr>
-              <a:t>가까이 볼 곳부터</a:t>
+              <a:t>위험한 지점부터 번호를 매겨</a:t>
             </a:r>
             <a:endParaRPr lang="en-US" sz="1250" dirty="0"/>
           </a:p>
           <a:p>
-            <a:pPr marL="0" indent="0">
+            <a:pPr indent="0" marL="0">
               <a:buNone/>
             </a:pPr>
             <a:r>
@@ -8666,7 +8226,46 @@
       </p:sp>
       <p:sp>
         <p:nvSpPr>
-          <p:cNvPr id="38" name="Shape 31"/>
+          <p:cNvPr id="44" name="Text 36"/>
+          <p:cNvSpPr txBox="1"/>
+          <p:nvPr/>
+        </p:nvSpPr>
+        <p:spPr>
+          <a:xfrm>
+            <a:off x="9311335" y="1051560"/>
+            <a:ext cx="2331720" cy="228600"/>
+          </a:xfrm>
+          <a:prstGeom prst="rect">
+            <a:avLst/>
+          </a:prstGeom>
+          <a:noFill/>
+          <a:ln/>
+        </p:spPr>
+        <p:txBody>
+          <a:bodyPr wrap="square" lIns="0" tIns="0" rIns="0" bIns="0" rtlCol="0" anchor="t"/>
+          <a:lstStyle/>
+          <a:p>
+            <a:pPr algn="r" indent="0" marL="0">
+              <a:buNone/>
+            </a:pPr>
+            <a:r>
+              <a:rPr lang="en-US" sz="1000" i="1" dirty="0">
+                <a:solidFill>
+                  <a:srgbClr val="A3A7AD"/>
+                </a:solidFill>
+                <a:latin typeface="맑은 고딕" pitchFamily="34" charset="0"/>
+                <a:ea typeface="맑은 고딕" pitchFamily="34" charset="-122"/>
+                <a:cs typeface="맑은 고딕" pitchFamily="34" charset="-120"/>
+              </a:rPr>
+              <a:t>예시 화면 (개념도)</a:t>
+            </a:r>
+            <a:endParaRPr lang="en-US" sz="1000" dirty="0"/>
+          </a:p>
+        </p:txBody>
+      </p:sp>
+      <p:sp>
+        <p:nvSpPr>
+          <p:cNvPr id="45" name="Shape 37"/>
           <p:cNvSpPr/>
           <p:nvPr/>
         </p:nvSpPr>
@@ -8693,7 +8292,7 @@
       </p:sp>
       <p:sp>
         <p:nvSpPr>
-          <p:cNvPr id="39" name="Text 32"/>
+          <p:cNvPr id="46" name="Text 38"/>
           <p:cNvSpPr txBox="1"/>
           <p:nvPr/>
         </p:nvSpPr>
@@ -8712,7 +8311,7 @@
           <a:bodyPr wrap="square" lIns="0" tIns="0" rIns="0" bIns="0" rtlCol="0" anchor="ctr"/>
           <a:lstStyle/>
           <a:p>
-            <a:pPr marL="0" indent="0" algn="ctr">
+            <a:pPr algn="ctr" indent="0" marL="0">
               <a:buNone/>
             </a:pPr>
             <a:r>
@@ -8732,7 +8331,7 @@
       </p:sp>
       <p:sp>
         <p:nvSpPr>
-          <p:cNvPr id="40" name="Shape 33"/>
+          <p:cNvPr id="47" name="Shape 39"/>
           <p:cNvSpPr/>
           <p:nvPr/>
         </p:nvSpPr>
@@ -8759,7 +8358,7 @@
       </p:sp>
       <p:sp>
         <p:nvSpPr>
-          <p:cNvPr id="41" name="Text 34"/>
+          <p:cNvPr id="48" name="Text 40"/>
           <p:cNvSpPr txBox="1"/>
           <p:nvPr/>
         </p:nvSpPr>
@@ -8778,7 +8377,7 @@
           <a:bodyPr wrap="square" lIns="0" tIns="0" rIns="0" bIns="0" rtlCol="0" anchor="ctr"/>
           <a:lstStyle/>
           <a:p>
-            <a:pPr marL="0" indent="0" algn="ctr">
+            <a:pPr algn="ctr" indent="0" marL="0">
               <a:buNone/>
             </a:pPr>
             <a:r>
@@ -8798,7 +8397,7 @@
       </p:sp>
       <p:sp>
         <p:nvSpPr>
-          <p:cNvPr id="42" name="Shape 35"/>
+          <p:cNvPr id="49" name="Shape 41"/>
           <p:cNvSpPr/>
           <p:nvPr/>
         </p:nvSpPr>
@@ -8825,7 +8424,7 @@
       </p:sp>
       <p:sp>
         <p:nvSpPr>
-          <p:cNvPr id="43" name="Text 36"/>
+          <p:cNvPr id="50" name="Text 42"/>
           <p:cNvSpPr txBox="1"/>
           <p:nvPr/>
         </p:nvSpPr>
@@ -8844,7 +8443,7 @@
           <a:bodyPr wrap="square" lIns="0" tIns="0" rIns="0" bIns="0" rtlCol="0" anchor="ctr"/>
           <a:lstStyle/>
           <a:p>
-            <a:pPr marL="0" indent="0" algn="ctr">
+            <a:pPr algn="ctr" indent="0" marL="0">
               <a:buNone/>
             </a:pPr>
             <a:r>
@@ -8859,45 +8458,6 @@
               <a:t>개인 판단이 아닌 데이터 리포트</a:t>
             </a:r>
             <a:endParaRPr lang="en-US" sz="1300" dirty="0"/>
-          </a:p>
-        </p:txBody>
-      </p:sp>
-      <p:sp>
-        <p:nvSpPr>
-          <p:cNvPr id="44" name="Text 37"/>
-          <p:cNvSpPr txBox="1"/>
-          <p:nvPr/>
-        </p:nvSpPr>
-        <p:spPr>
-          <a:xfrm>
-            <a:off x="9311335" y="1051560"/>
-            <a:ext cx="2331720" cy="228600"/>
-          </a:xfrm>
-          <a:prstGeom prst="rect">
-            <a:avLst/>
-          </a:prstGeom>
-          <a:noFill/>
-          <a:ln/>
-        </p:spPr>
-        <p:txBody>
-          <a:bodyPr wrap="square" lIns="0" tIns="0" rIns="0" bIns="0" rtlCol="0" anchor="t"/>
-          <a:lstStyle/>
-          <a:p>
-            <a:pPr marL="0" indent="0" algn="r">
-              <a:buNone/>
-            </a:pPr>
-            <a:r>
-              <a:rPr lang="en-US" sz="1000" i="1" dirty="0">
-                <a:solidFill>
-                  <a:srgbClr val="A3A7AD"/>
-                </a:solidFill>
-                <a:latin typeface="맑은 고딕" pitchFamily="34" charset="0"/>
-                <a:ea typeface="맑은 고딕" pitchFamily="34" charset="-122"/>
-                <a:cs typeface="맑은 고딕" pitchFamily="34" charset="-120"/>
-              </a:rPr>
-              <a:t>예시 화면 (개념도)</a:t>
-            </a:r>
-            <a:endParaRPr lang="en-US" sz="1000" dirty="0"/>
           </a:p>
         </p:txBody>
       </p:sp>
@@ -8911,13 +8471,12 @@
 
 <file path=ppt/slides/slide7.xml><?xml version="1.0" encoding="utf-8"?>
 <p:sld xmlns:a="http://schemas.openxmlformats.org/drawingml/2006/main" xmlns:r="http://schemas.openxmlformats.org/officeDocument/2006/relationships" xmlns:p="http://schemas.openxmlformats.org/presentationml/2006/main">
-  <p:cSld name="Slide 6">
+  <p:cSld name="Slide 2">
     <p:bg>
       <p:bgPr>
         <a:solidFill>
           <a:srgbClr val="FFFFFF"/>
         </a:solidFill>
-        <a:effectLst/>
       </p:bgPr>
     </p:bg>
     <p:spTree>
@@ -8955,11 +8514,11 @@
           <a:bodyPr wrap="square" lIns="0" tIns="0" rIns="0" bIns="0" rtlCol="0" anchor="t"/>
           <a:lstStyle/>
           <a:p>
-            <a:pPr marL="0" indent="0">
-              <a:buNone/>
-            </a:pPr>
-            <a:r>
-              <a:rPr lang="en-US" sz="1200" b="1" kern="0" spc="100" dirty="0">
+            <a:pPr indent="0" marL="0">
+              <a:buNone/>
+            </a:pPr>
+            <a:r>
+              <a:rPr lang="en-US" sz="1200" b="1" spc="100" kern="0" dirty="0">
                 <a:solidFill>
                   <a:srgbClr val="B5501F"/>
                 </a:solidFill>
@@ -8994,7 +8553,7 @@
           <a:bodyPr wrap="square" lIns="0" tIns="0" rIns="0" bIns="0" rtlCol="0" anchor="ctr"/>
           <a:lstStyle/>
           <a:p>
-            <a:pPr marL="0" indent="0">
+            <a:pPr indent="0" marL="0">
               <a:buNone/>
             </a:pPr>
             <a:r>
@@ -9033,7 +8592,7 @@
           <a:bodyPr wrap="square" lIns="0" tIns="0" rIns="0" bIns="0" rtlCol="0" anchor="t"/>
           <a:lstStyle/>
           <a:p>
-            <a:pPr marL="0" indent="0">
+            <a:pPr indent="0" marL="0">
               <a:buNone/>
             </a:pPr>
             <a:r>
@@ -9045,29 +8604,7 @@
                 <a:ea typeface="맑은 고딕" pitchFamily="34" charset="-122"/>
                 <a:cs typeface="맑은 고딕" pitchFamily="34" charset="-120"/>
               </a:rPr>
-              <a:t>MLC  ·  </a:t>
-            </a:r>
-            <a:r>
-              <a:rPr lang="en-US" sz="900" dirty="0" err="1">
-                <a:solidFill>
-                  <a:srgbClr val="A3A7AD"/>
-                </a:solidFill>
-                <a:latin typeface="맑은 고딕" pitchFamily="34" charset="0"/>
-                <a:ea typeface="맑은 고딕" pitchFamily="34" charset="-122"/>
-                <a:cs typeface="맑은 고딕" pitchFamily="34" charset="-120"/>
-              </a:rPr>
-              <a:t>제주</a:t>
-            </a:r>
-            <a:r>
-              <a:rPr lang="en-US" sz="900" dirty="0">
-                <a:solidFill>
-                  <a:srgbClr val="A3A7AD"/>
-                </a:solidFill>
-                <a:latin typeface="맑은 고딕" pitchFamily="34" charset="0"/>
-                <a:ea typeface="맑은 고딕" pitchFamily="34" charset="-122"/>
-                <a:cs typeface="맑은 고딕" pitchFamily="34" charset="-120"/>
-              </a:rPr>
-              <a:t> A-STREAM 2026</a:t>
+              <a:t>MLC  ·  제주 A-STREAM 2026</a:t>
             </a:r>
             <a:endParaRPr lang="en-US" sz="900" dirty="0"/>
           </a:p>
@@ -9094,7 +8631,7 @@
           <a:bodyPr wrap="square" lIns="0" tIns="0" rIns="0" bIns="0" rtlCol="0" anchor="t"/>
           <a:lstStyle/>
           <a:p>
-            <a:pPr marL="0" indent="0" algn="r">
+            <a:pPr algn="r" indent="0" marL="0">
               <a:buNone/>
             </a:pPr>
             <a:r>
@@ -9114,111 +8651,911 @@
       </p:sp>
       <p:sp>
         <p:nvSpPr>
-          <p:cNvPr id="6" name="Shape 4"/>
+          <p:cNvPr id="6" name="Text 4"/>
+          <p:cNvSpPr txBox="1"/>
+          <p:nvPr/>
+        </p:nvSpPr>
+        <p:spPr>
+          <a:xfrm>
+            <a:off x="548640" y="2331720"/>
+            <a:ext cx="1417320" cy="365760"/>
+          </a:xfrm>
+          <a:prstGeom prst="rect">
+            <a:avLst/>
+          </a:prstGeom>
+          <a:noFill/>
+          <a:ln/>
+        </p:spPr>
+        <p:txBody>
+          <a:bodyPr wrap="square" lIns="0" tIns="0" rIns="0" bIns="0" rtlCol="0" anchor="ctr"/>
+          <a:lstStyle/>
+          <a:p>
+            <a:pPr indent="0" marL="0">
+              <a:buNone/>
+            </a:pPr>
+            <a:r>
+              <a:rPr lang="en-US" sz="1400" b="1" dirty="0">
+                <a:solidFill>
+                  <a:srgbClr val="6B6F76"/>
+                </a:solidFill>
+                <a:latin typeface="맑은 고딕" pitchFamily="34" charset="0"/>
+                <a:ea typeface="맑은 고딕" pitchFamily="34" charset="-122"/>
+                <a:cs typeface="맑은 고딕" pitchFamily="34" charset="-120"/>
+              </a:rPr>
+              <a:t>표면 사진</a:t>
+            </a:r>
+            <a:endParaRPr lang="en-US" sz="1400" dirty="0"/>
+          </a:p>
+        </p:txBody>
+      </p:sp>
+      <p:sp>
+        <p:nvSpPr>
+          <p:cNvPr id="7" name="Text 5"/>
+          <p:cNvSpPr txBox="1"/>
+          <p:nvPr/>
+        </p:nvSpPr>
+        <p:spPr>
+          <a:xfrm>
+            <a:off x="548640" y="3721608"/>
+            <a:ext cx="1417320" cy="365760"/>
+          </a:xfrm>
+          <a:prstGeom prst="rect">
+            <a:avLst/>
+          </a:prstGeom>
+          <a:noFill/>
+          <a:ln/>
+        </p:spPr>
+        <p:txBody>
+          <a:bodyPr wrap="square" lIns="0" tIns="0" rIns="0" bIns="0" rtlCol="0" anchor="ctr"/>
+          <a:lstStyle/>
+          <a:p>
+            <a:pPr indent="0" marL="0">
+              <a:buNone/>
+            </a:pPr>
+            <a:r>
+              <a:rPr lang="en-US" sz="1400" b="1" dirty="0">
+                <a:solidFill>
+                  <a:srgbClr val="6B6F76"/>
+                </a:solidFill>
+                <a:latin typeface="맑은 고딕" pitchFamily="34" charset="0"/>
+                <a:ea typeface="맑은 고딕" pitchFamily="34" charset="-122"/>
+                <a:cs typeface="맑은 고딕" pitchFamily="34" charset="-120"/>
+              </a:rPr>
+              <a:t>녹의 색</a:t>
+            </a:r>
+            <a:endParaRPr lang="en-US" sz="1400" dirty="0"/>
+          </a:p>
+        </p:txBody>
+      </p:sp>
+      <p:sp>
+        <p:nvSpPr>
+          <p:cNvPr id="8" name="Text 6"/>
+          <p:cNvSpPr txBox="1"/>
+          <p:nvPr/>
+        </p:nvSpPr>
+        <p:spPr>
+          <a:xfrm>
+            <a:off x="548640" y="4617720"/>
+            <a:ext cx="1417320" cy="365760"/>
+          </a:xfrm>
+          <a:prstGeom prst="rect">
+            <a:avLst/>
+          </a:prstGeom>
+          <a:noFill/>
+          <a:ln/>
+        </p:spPr>
+        <p:txBody>
+          <a:bodyPr wrap="square" lIns="0" tIns="0" rIns="0" bIns="0" rtlCol="0" anchor="ctr"/>
+          <a:lstStyle/>
+          <a:p>
+            <a:pPr indent="0" marL="0">
+              <a:buNone/>
+            </a:pPr>
+            <a:r>
+              <a:rPr lang="en-US" sz="1400" b="1" dirty="0">
+                <a:solidFill>
+                  <a:srgbClr val="6B6F76"/>
+                </a:solidFill>
+                <a:latin typeface="맑은 고딕" pitchFamily="34" charset="0"/>
+                <a:ea typeface="맑은 고딕" pitchFamily="34" charset="-122"/>
+                <a:cs typeface="맑은 고딕" pitchFamily="34" charset="-120"/>
+              </a:rPr>
+              <a:t>부식 속도</a:t>
+            </a:r>
+            <a:endParaRPr lang="en-US" sz="1400" dirty="0"/>
+          </a:p>
+        </p:txBody>
+      </p:sp>
+      <p:sp>
+        <p:nvSpPr>
+          <p:cNvPr id="9" name="Shape 7"/>
           <p:cNvSpPr/>
           <p:nvPr/>
         </p:nvSpPr>
         <p:spPr>
           <a:xfrm>
-            <a:off x="1737982" y="4526050"/>
-            <a:ext cx="1042365" cy="663655"/>
+            <a:off x="2877769" y="1325880"/>
+            <a:ext cx="1554480" cy="329184"/>
           </a:xfrm>
           <a:prstGeom prst="roundRect">
             <a:avLst>
-              <a:gd name="adj" fmla="val 8267"/>
+              <a:gd name="adj" fmla="val 50000"/>
             </a:avLst>
           </a:prstGeom>
           <a:solidFill>
-            <a:srgbClr val="E6EEF7"/>
+            <a:srgbClr val="3A6EA5"/>
           </a:solidFill>
           <a:ln w="12700">
             <a:solidFill>
               <a:srgbClr val="3A6EA5"/>
             </a:solidFill>
-            <a:prstDash val="dash"/>
+            <a:prstDash val="solid"/>
           </a:ln>
         </p:spPr>
       </p:sp>
       <p:sp>
         <p:nvSpPr>
-          <p:cNvPr id="7" name="Shape 5"/>
+          <p:cNvPr id="10" name="Text 8"/>
+          <p:cNvSpPr txBox="1"/>
+          <p:nvPr/>
+        </p:nvSpPr>
+        <p:spPr>
+          <a:xfrm>
+            <a:off x="2877769" y="1325880"/>
+            <a:ext cx="1554480" cy="329184"/>
+          </a:xfrm>
+          <a:prstGeom prst="rect">
+            <a:avLst/>
+          </a:prstGeom>
+          <a:noFill/>
+          <a:ln/>
+        </p:spPr>
+        <p:txBody>
+          <a:bodyPr wrap="square" lIns="0" tIns="0" rIns="0" bIns="0" rtlCol="0" anchor="ctr"/>
+          <a:lstStyle/>
+          <a:p>
+            <a:pPr algn="ctr" indent="0" marL="0">
+              <a:buNone/>
+            </a:pPr>
+            <a:r>
+              <a:rPr lang="en-US" sz="1300" b="1" dirty="0">
+                <a:solidFill>
+                  <a:srgbClr val="FFFFFF"/>
+                </a:solidFill>
+                <a:latin typeface="맑은 고딕" pitchFamily="34" charset="0"/>
+                <a:ea typeface="맑은 고딕" pitchFamily="34" charset="-122"/>
+                <a:cs typeface="맑은 고딕" pitchFamily="34" charset="-120"/>
+              </a:rPr>
+              <a:t>위험도  낮음</a:t>
+            </a:r>
+            <a:endParaRPr lang="en-US" sz="1300" dirty="0"/>
+          </a:p>
+        </p:txBody>
+      </p:sp>
+      <p:pic>
+        <p:nvPicPr>
+          <p:cNvPr id="11" name="Image 0" descr="/home/user/PPT/src/img/photo_3.png">    </p:cNvPr>
+          <p:cNvPicPr>
+            <a:picLocks noChangeAspect="1"/>
+          </p:cNvPicPr>
+          <p:nvPr/>
+        </p:nvPicPr>
+        <p:blipFill>
+          <a:blip r:embed="rId1"/>
+          <a:stretch>
+            <a:fillRect/>
+          </a:stretch>
+        </p:blipFill>
+        <p:spPr>
+          <a:xfrm>
+            <a:off x="2809189" y="1737360"/>
+            <a:ext cx="1691640" cy="1691640"/>
+          </a:xfrm>
+          <a:prstGeom prst="rect">
+            <a:avLst/>
+          </a:prstGeom>
+        </p:spPr>
+      </p:pic>
+      <p:sp>
+        <p:nvSpPr>
+          <p:cNvPr id="12" name="Text 9"/>
+          <p:cNvSpPr txBox="1"/>
+          <p:nvPr/>
+        </p:nvSpPr>
+        <p:spPr>
+          <a:xfrm>
+            <a:off x="2809189" y="3136392"/>
+            <a:ext cx="1618488" cy="256032"/>
+          </a:xfrm>
+          <a:prstGeom prst="rect">
+            <a:avLst/>
+          </a:prstGeom>
+          <a:noFill/>
+          <a:ln/>
+        </p:spPr>
+        <p:txBody>
+          <a:bodyPr wrap="square" lIns="0" tIns="0" rIns="0" bIns="0" rtlCol="0" anchor="ctr"/>
+          <a:lstStyle/>
+          <a:p>
+            <a:pPr algn="r" indent="0" marL="0">
+              <a:buNone/>
+            </a:pPr>
+            <a:r>
+              <a:rPr lang="en-US" sz="1050" b="1" dirty="0">
+                <a:solidFill>
+                  <a:srgbClr val="FFFFFF"/>
+                </a:solidFill>
+                <a:latin typeface="맑은 고딕" pitchFamily="34" charset="0"/>
+                <a:ea typeface="맑은 고딕" pitchFamily="34" charset="-122"/>
+                <a:cs typeface="맑은 고딕" pitchFamily="34" charset="-120"/>
+              </a:rPr>
+              <a:t>24 h</a:t>
+            </a:r>
+            <a:endParaRPr lang="en-US" sz="1050" dirty="0"/>
+          </a:p>
+        </p:txBody>
+      </p:sp>
+      <p:sp>
+        <p:nvSpPr>
+          <p:cNvPr id="13" name="Shape 10"/>
           <p:cNvSpPr/>
           <p:nvPr/>
         </p:nvSpPr>
         <p:spPr>
           <a:xfrm>
-            <a:off x="3822713" y="3749137"/>
-            <a:ext cx="1870126" cy="782875"/>
+            <a:off x="2809189" y="3657600"/>
+            <a:ext cx="1691640" cy="502920"/>
+          </a:xfrm>
+          <a:prstGeom prst="rect">
+            <a:avLst/>
+          </a:prstGeom>
+          <a:solidFill>
+            <a:srgbClr val="4B4A48"/>
+          </a:solidFill>
+          <a:ln w="12700">
+            <a:solidFill>
+              <a:srgbClr val="D9DCE0"/>
+            </a:solidFill>
+            <a:prstDash val="solid"/>
+          </a:ln>
+        </p:spPr>
+      </p:sp>
+      <p:sp>
+        <p:nvSpPr>
+          <p:cNvPr id="14" name="Text 11"/>
+          <p:cNvSpPr txBox="1"/>
+          <p:nvPr/>
+        </p:nvSpPr>
+        <p:spPr>
+          <a:xfrm>
+            <a:off x="2809189" y="3657600"/>
+            <a:ext cx="1691640" cy="502920"/>
+          </a:xfrm>
+          <a:prstGeom prst="rect">
+            <a:avLst/>
+          </a:prstGeom>
+          <a:noFill/>
+          <a:ln/>
+        </p:spPr>
+        <p:txBody>
+          <a:bodyPr wrap="square" lIns="0" tIns="0" rIns="0" bIns="0" rtlCol="0" anchor="ctr"/>
+          <a:lstStyle/>
+          <a:p>
+            <a:pPr algn="ctr" indent="0" marL="0">
+              <a:buNone/>
+            </a:pPr>
+            <a:r>
+              <a:rPr lang="en-US" sz="1600" b="1" dirty="0">
+                <a:solidFill>
+                  <a:srgbClr val="FFFFFF"/>
+                </a:solidFill>
+                <a:latin typeface="맑은 고딕" pitchFamily="34" charset="0"/>
+                <a:ea typeface="맑은 고딕" pitchFamily="34" charset="-122"/>
+                <a:cs typeface="맑은 고딕" pitchFamily="34" charset="-120"/>
+              </a:rPr>
+              <a:t>b*  1.7</a:t>
+            </a:r>
+            <a:endParaRPr lang="en-US" sz="1600" dirty="0"/>
+          </a:p>
+        </p:txBody>
+      </p:sp>
+      <p:sp>
+        <p:nvSpPr>
+          <p:cNvPr id="15" name="Shape 12"/>
+          <p:cNvSpPr/>
+          <p:nvPr/>
+        </p:nvSpPr>
+        <p:spPr>
+          <a:xfrm>
+            <a:off x="3197809" y="5215548"/>
+            <a:ext cx="914400" cy="225132"/>
+          </a:xfrm>
+          <a:prstGeom prst="rect">
+            <a:avLst/>
+          </a:prstGeom>
+          <a:solidFill>
+            <a:srgbClr val="3A6EA5"/>
+          </a:solidFill>
+          <a:ln w="12700">
+            <a:solidFill>
+              <a:srgbClr val="3A6EA5"/>
+            </a:solidFill>
+            <a:prstDash val="solid"/>
+          </a:ln>
+        </p:spPr>
+      </p:sp>
+      <p:sp>
+        <p:nvSpPr>
+          <p:cNvPr id="16" name="Text 13"/>
+          <p:cNvSpPr txBox="1"/>
+          <p:nvPr/>
+        </p:nvSpPr>
+        <p:spPr>
+          <a:xfrm>
+            <a:off x="2740609" y="4904652"/>
+            <a:ext cx="1828800" cy="274320"/>
+          </a:xfrm>
+          <a:prstGeom prst="rect">
+            <a:avLst/>
+          </a:prstGeom>
+          <a:noFill/>
+          <a:ln/>
+        </p:spPr>
+        <p:txBody>
+          <a:bodyPr wrap="square" lIns="0" tIns="0" rIns="0" bIns="0" rtlCol="0" anchor="t"/>
+          <a:lstStyle/>
+          <a:p>
+            <a:pPr algn="ctr" indent="0" marL="0">
+              <a:buNone/>
+            </a:pPr>
+            <a:r>
+              <a:rPr lang="en-US" sz="1300" b="1" dirty="0">
+                <a:solidFill>
+                  <a:srgbClr val="3A6EA5"/>
+                </a:solidFill>
+                <a:latin typeface="맑은 고딕" pitchFamily="34" charset="0"/>
+                <a:ea typeface="맑은 고딕" pitchFamily="34" charset="-122"/>
+                <a:cs typeface="맑은 고딕" pitchFamily="34" charset="-120"/>
+              </a:rPr>
+              <a:t>0.34 mm/년</a:t>
+            </a:r>
+            <a:endParaRPr lang="en-US" sz="1300" dirty="0"/>
+          </a:p>
+        </p:txBody>
+      </p:sp>
+      <p:pic>
+        <p:nvPicPr>
+          <p:cNvPr id="17" name="Image 1" descr="preencoded.png">    </p:cNvPr>
+          <p:cNvPicPr>
+            <a:picLocks noChangeAspect="1"/>
+          </p:cNvPicPr>
+          <p:nvPr/>
+        </p:nvPicPr>
+        <p:blipFill>
+          <a:blip r:embed="rId2"/>
+          <a:stretch>
+            <a:fillRect/>
+          </a:stretch>
+        </p:blipFill>
+        <p:spPr>
+          <a:xfrm>
+            <a:off x="5097170" y="2427732"/>
+            <a:ext cx="310896" cy="310896"/>
+          </a:xfrm>
+          <a:prstGeom prst="rect">
+            <a:avLst/>
+          </a:prstGeom>
+        </p:spPr>
+      </p:pic>
+      <p:sp>
+        <p:nvSpPr>
+          <p:cNvPr id="18" name="Shape 14"/>
+          <p:cNvSpPr/>
+          <p:nvPr/>
+        </p:nvSpPr>
+        <p:spPr>
+          <a:xfrm>
+            <a:off x="6072988" y="1325880"/>
+            <a:ext cx="1554480" cy="329184"/>
           </a:xfrm>
           <a:prstGeom prst="roundRect">
             <a:avLst>
-              <a:gd name="adj" fmla="val 7008"/>
+              <a:gd name="adj" fmla="val 50000"/>
             </a:avLst>
           </a:prstGeom>
           <a:solidFill>
-            <a:srgbClr val="E5F2EA"/>
+            <a:srgbClr val="3C8D5A"/>
           </a:solidFill>
           <a:ln w="12700">
             <a:solidFill>
               <a:srgbClr val="3C8D5A"/>
             </a:solidFill>
-            <a:prstDash val="dash"/>
+            <a:prstDash val="solid"/>
           </a:ln>
         </p:spPr>
       </p:sp>
       <p:sp>
         <p:nvSpPr>
-          <p:cNvPr id="8" name="Shape 6"/>
+          <p:cNvPr id="19" name="Text 15"/>
+          <p:cNvSpPr txBox="1"/>
+          <p:nvPr/>
+        </p:nvSpPr>
+        <p:spPr>
+          <a:xfrm>
+            <a:off x="6072988" y="1325880"/>
+            <a:ext cx="1554480" cy="329184"/>
+          </a:xfrm>
+          <a:prstGeom prst="rect">
+            <a:avLst/>
+          </a:prstGeom>
+          <a:noFill/>
+          <a:ln/>
+        </p:spPr>
+        <p:txBody>
+          <a:bodyPr wrap="square" lIns="0" tIns="0" rIns="0" bIns="0" rtlCol="0" anchor="ctr"/>
+          <a:lstStyle/>
+          <a:p>
+            <a:pPr algn="ctr" indent="0" marL="0">
+              <a:buNone/>
+            </a:pPr>
+            <a:r>
+              <a:rPr lang="en-US" sz="1300" b="1" dirty="0">
+                <a:solidFill>
+                  <a:srgbClr val="FFFFFF"/>
+                </a:solidFill>
+                <a:latin typeface="맑은 고딕" pitchFamily="34" charset="0"/>
+                <a:ea typeface="맑은 고딕" pitchFamily="34" charset="-122"/>
+                <a:cs typeface="맑은 고딕" pitchFamily="34" charset="-120"/>
+              </a:rPr>
+              <a:t>위험도  중간</a:t>
+            </a:r>
+            <a:endParaRPr lang="en-US" sz="1300" dirty="0"/>
+          </a:p>
+        </p:txBody>
+      </p:sp>
+      <p:pic>
+        <p:nvPicPr>
+          <p:cNvPr id="20" name="Image 2" descr="/home/user/PPT/src/img/photo_15.png">    </p:cNvPr>
+          <p:cNvPicPr>
+            <a:picLocks noChangeAspect="1"/>
+          </p:cNvPicPr>
+          <p:nvPr/>
+        </p:nvPicPr>
+        <p:blipFill>
+          <a:blip r:embed="rId3"/>
+          <a:stretch>
+            <a:fillRect/>
+          </a:stretch>
+        </p:blipFill>
+        <p:spPr>
+          <a:xfrm>
+            <a:off x="6004408" y="1737360"/>
+            <a:ext cx="1691640" cy="1691640"/>
+          </a:xfrm>
+          <a:prstGeom prst="rect">
+            <a:avLst/>
+          </a:prstGeom>
+        </p:spPr>
+      </p:pic>
+      <p:sp>
+        <p:nvSpPr>
+          <p:cNvPr id="21" name="Text 16"/>
+          <p:cNvSpPr txBox="1"/>
+          <p:nvPr/>
+        </p:nvSpPr>
+        <p:spPr>
+          <a:xfrm>
+            <a:off x="6004408" y="3136392"/>
+            <a:ext cx="1618488" cy="256032"/>
+          </a:xfrm>
+          <a:prstGeom prst="rect">
+            <a:avLst/>
+          </a:prstGeom>
+          <a:noFill/>
+          <a:ln/>
+        </p:spPr>
+        <p:txBody>
+          <a:bodyPr wrap="square" lIns="0" tIns="0" rIns="0" bIns="0" rtlCol="0" anchor="ctr"/>
+          <a:lstStyle/>
+          <a:p>
+            <a:pPr algn="r" indent="0" marL="0">
+              <a:buNone/>
+            </a:pPr>
+            <a:r>
+              <a:rPr lang="en-US" sz="1050" b="1" dirty="0">
+                <a:solidFill>
+                  <a:srgbClr val="FFFFFF"/>
+                </a:solidFill>
+                <a:latin typeface="맑은 고딕" pitchFamily="34" charset="0"/>
+                <a:ea typeface="맑은 고딕" pitchFamily="34" charset="-122"/>
+                <a:cs typeface="맑은 고딕" pitchFamily="34" charset="-120"/>
+              </a:rPr>
+              <a:t>120 h</a:t>
+            </a:r>
+            <a:endParaRPr lang="en-US" sz="1050" dirty="0"/>
+          </a:p>
+        </p:txBody>
+      </p:sp>
+      <p:sp>
+        <p:nvSpPr>
+          <p:cNvPr id="22" name="Shape 17"/>
           <p:cNvSpPr/>
           <p:nvPr/>
         </p:nvSpPr>
         <p:spPr>
           <a:xfrm>
-            <a:off x="5508892" y="1946936"/>
-            <a:ext cx="705129" cy="1289557"/>
+            <a:off x="6004408" y="3657600"/>
+            <a:ext cx="1691640" cy="502920"/>
+          </a:xfrm>
+          <a:prstGeom prst="rect">
+            <a:avLst/>
+          </a:prstGeom>
+          <a:solidFill>
+            <a:srgbClr val="4B4034"/>
+          </a:solidFill>
+          <a:ln w="12700">
+            <a:solidFill>
+              <a:srgbClr val="D9DCE0"/>
+            </a:solidFill>
+            <a:prstDash val="solid"/>
+          </a:ln>
+        </p:spPr>
+      </p:sp>
+      <p:sp>
+        <p:nvSpPr>
+          <p:cNvPr id="23" name="Text 18"/>
+          <p:cNvSpPr txBox="1"/>
+          <p:nvPr/>
+        </p:nvSpPr>
+        <p:spPr>
+          <a:xfrm>
+            <a:off x="6004408" y="3657600"/>
+            <a:ext cx="1691640" cy="502920"/>
+          </a:xfrm>
+          <a:prstGeom prst="rect">
+            <a:avLst/>
+          </a:prstGeom>
+          <a:noFill/>
+          <a:ln/>
+        </p:spPr>
+        <p:txBody>
+          <a:bodyPr wrap="square" lIns="0" tIns="0" rIns="0" bIns="0" rtlCol="0" anchor="ctr"/>
+          <a:lstStyle/>
+          <a:p>
+            <a:pPr algn="ctr" indent="0" marL="0">
+              <a:buNone/>
+            </a:pPr>
+            <a:r>
+              <a:rPr lang="en-US" sz="1600" b="1" dirty="0">
+                <a:solidFill>
+                  <a:srgbClr val="FFFFFF"/>
+                </a:solidFill>
+                <a:latin typeface="맑은 고딕" pitchFamily="34" charset="0"/>
+                <a:ea typeface="맑은 고딕" pitchFamily="34" charset="-122"/>
+                <a:cs typeface="맑은 고딕" pitchFamily="34" charset="-120"/>
+              </a:rPr>
+              <a:t>b*  9.4</a:t>
+            </a:r>
+            <a:endParaRPr lang="en-US" sz="1600" dirty="0"/>
+          </a:p>
+        </p:txBody>
+      </p:sp>
+      <p:sp>
+        <p:nvSpPr>
+          <p:cNvPr id="24" name="Shape 19"/>
+          <p:cNvSpPr/>
+          <p:nvPr/>
+        </p:nvSpPr>
+        <p:spPr>
+          <a:xfrm>
+            <a:off x="6393028" y="4990417"/>
+            <a:ext cx="914400" cy="450263"/>
+          </a:xfrm>
+          <a:prstGeom prst="rect">
+            <a:avLst/>
+          </a:prstGeom>
+          <a:solidFill>
+            <a:srgbClr val="3C8D5A"/>
+          </a:solidFill>
+          <a:ln w="12700">
+            <a:solidFill>
+              <a:srgbClr val="3C8D5A"/>
+            </a:solidFill>
+            <a:prstDash val="solid"/>
+          </a:ln>
+        </p:spPr>
+      </p:sp>
+      <p:sp>
+        <p:nvSpPr>
+          <p:cNvPr id="25" name="Text 20"/>
+          <p:cNvSpPr txBox="1"/>
+          <p:nvPr/>
+        </p:nvSpPr>
+        <p:spPr>
+          <a:xfrm>
+            <a:off x="5935828" y="4679521"/>
+            <a:ext cx="1828800" cy="274320"/>
+          </a:xfrm>
+          <a:prstGeom prst="rect">
+            <a:avLst/>
+          </a:prstGeom>
+          <a:noFill/>
+          <a:ln/>
+        </p:spPr>
+        <p:txBody>
+          <a:bodyPr wrap="square" lIns="0" tIns="0" rIns="0" bIns="0" rtlCol="0" anchor="t"/>
+          <a:lstStyle/>
+          <a:p>
+            <a:pPr algn="ctr" indent="0" marL="0">
+              <a:buNone/>
+            </a:pPr>
+            <a:r>
+              <a:rPr lang="en-US" sz="1300" b="1" dirty="0">
+                <a:solidFill>
+                  <a:srgbClr val="3C8D5A"/>
+                </a:solidFill>
+                <a:latin typeface="맑은 고딕" pitchFamily="34" charset="0"/>
+                <a:ea typeface="맑은 고딕" pitchFamily="34" charset="-122"/>
+                <a:cs typeface="맑은 고딕" pitchFamily="34" charset="-120"/>
+              </a:rPr>
+              <a:t>0.68 mm/년</a:t>
+            </a:r>
+            <a:endParaRPr lang="en-US" sz="1300" dirty="0"/>
+          </a:p>
+        </p:txBody>
+      </p:sp>
+      <p:pic>
+        <p:nvPicPr>
+          <p:cNvPr id="26" name="Image 3" descr="preencoded.png">    </p:cNvPr>
+          <p:cNvPicPr>
+            <a:picLocks noChangeAspect="1"/>
+          </p:cNvPicPr>
+          <p:nvPr/>
+        </p:nvPicPr>
+        <p:blipFill>
+          <a:blip r:embed="rId4"/>
+          <a:stretch>
+            <a:fillRect/>
+          </a:stretch>
+        </p:blipFill>
+        <p:spPr>
+          <a:xfrm>
+            <a:off x="8292389" y="2427732"/>
+            <a:ext cx="310896" cy="310896"/>
+          </a:xfrm>
+          <a:prstGeom prst="rect">
+            <a:avLst/>
+          </a:prstGeom>
+        </p:spPr>
+      </p:pic>
+      <p:sp>
+        <p:nvSpPr>
+          <p:cNvPr id="27" name="Shape 21"/>
+          <p:cNvSpPr/>
+          <p:nvPr/>
+        </p:nvSpPr>
+        <p:spPr>
+          <a:xfrm>
+            <a:off x="9268206" y="1325880"/>
+            <a:ext cx="1554480" cy="329184"/>
           </a:xfrm>
           <a:prstGeom prst="roundRect">
             <a:avLst>
-              <a:gd name="adj" fmla="val 7781"/>
+              <a:gd name="adj" fmla="val 50000"/>
             </a:avLst>
           </a:prstGeom>
           <a:solidFill>
-            <a:srgbClr val="F8E4E2"/>
+            <a:srgbClr val="B23A2E"/>
           </a:solidFill>
           <a:ln w="12700">
             <a:solidFill>
               <a:srgbClr val="B23A2E"/>
             </a:solidFill>
-            <a:prstDash val="dash"/>
+            <a:prstDash val="solid"/>
           </a:ln>
         </p:spPr>
       </p:sp>
-      <p:graphicFrame>
-        <p:nvGraphicFramePr>
-          <p:cNvPr id="9" name="Chart 0"/>
-          <p:cNvGraphicFramePr/>
-          <p:nvPr/>
-        </p:nvGraphicFramePr>
-        <p:xfrm>
-          <a:off x="548640" y="1325880"/>
-          <a:ext cx="6492240" cy="4846320"/>
-        </p:xfrm>
-        <a:graphic>
-          <a:graphicData uri="http://schemas.openxmlformats.org/drawingml/2006/chart">
-            <c:chart xmlns:c="http://schemas.openxmlformats.org/drawingml/2006/chart" xmlns:r="http://schemas.openxmlformats.org/officeDocument/2006/relationships" r:id="rId3"/>
-          </a:graphicData>
-        </a:graphic>
-      </p:graphicFrame>
-      <p:sp>
-        <p:nvSpPr>
-          <p:cNvPr id="10" name="Text 7"/>
-          <p:cNvSpPr txBox="1"/>
-          <p:nvPr/>
-        </p:nvSpPr>
-        <p:spPr>
-          <a:xfrm>
-            <a:off x="1768907" y="4221482"/>
-            <a:ext cx="1463040" cy="274320"/>
+      <p:sp>
+        <p:nvSpPr>
+          <p:cNvPr id="28" name="Text 22"/>
+          <p:cNvSpPr txBox="1"/>
+          <p:nvPr/>
+        </p:nvSpPr>
+        <p:spPr>
+          <a:xfrm>
+            <a:off x="9268206" y="1325880"/>
+            <a:ext cx="1554480" cy="329184"/>
+          </a:xfrm>
+          <a:prstGeom prst="rect">
+            <a:avLst/>
+          </a:prstGeom>
+          <a:noFill/>
+          <a:ln/>
+        </p:spPr>
+        <p:txBody>
+          <a:bodyPr wrap="square" lIns="0" tIns="0" rIns="0" bIns="0" rtlCol="0" anchor="ctr"/>
+          <a:lstStyle/>
+          <a:p>
+            <a:pPr algn="ctr" indent="0" marL="0">
+              <a:buNone/>
+            </a:pPr>
+            <a:r>
+              <a:rPr lang="en-US" sz="1300" b="1" dirty="0">
+                <a:solidFill>
+                  <a:srgbClr val="FFFFFF"/>
+                </a:solidFill>
+                <a:latin typeface="맑은 고딕" pitchFamily="34" charset="0"/>
+                <a:ea typeface="맑은 고딕" pitchFamily="34" charset="-122"/>
+                <a:cs typeface="맑은 고딕" pitchFamily="34" charset="-120"/>
+              </a:rPr>
+              <a:t>위험도  높음</a:t>
+            </a:r>
+            <a:endParaRPr lang="en-US" sz="1300" dirty="0"/>
+          </a:p>
+        </p:txBody>
+      </p:sp>
+      <p:pic>
+        <p:nvPicPr>
+          <p:cNvPr id="29" name="Image 4" descr="/home/user/PPT/src/img/photo_30.png">    </p:cNvPr>
+          <p:cNvPicPr>
+            <a:picLocks noChangeAspect="1"/>
+          </p:cNvPicPr>
+          <p:nvPr/>
+        </p:nvPicPr>
+        <p:blipFill>
+          <a:blip r:embed="rId5"/>
+          <a:stretch>
+            <a:fillRect/>
+          </a:stretch>
+        </p:blipFill>
+        <p:spPr>
+          <a:xfrm>
+            <a:off x="9199626" y="1737360"/>
+            <a:ext cx="1691640" cy="1691640"/>
+          </a:xfrm>
+          <a:prstGeom prst="rect">
+            <a:avLst/>
+          </a:prstGeom>
+        </p:spPr>
+      </p:pic>
+      <p:sp>
+        <p:nvSpPr>
+          <p:cNvPr id="30" name="Text 23"/>
+          <p:cNvSpPr txBox="1"/>
+          <p:nvPr/>
+        </p:nvSpPr>
+        <p:spPr>
+          <a:xfrm>
+            <a:off x="9199626" y="3136392"/>
+            <a:ext cx="1618488" cy="256032"/>
+          </a:xfrm>
+          <a:prstGeom prst="rect">
+            <a:avLst/>
+          </a:prstGeom>
+          <a:noFill/>
+          <a:ln/>
+        </p:spPr>
+        <p:txBody>
+          <a:bodyPr wrap="square" lIns="0" tIns="0" rIns="0" bIns="0" rtlCol="0" anchor="ctr"/>
+          <a:lstStyle/>
+          <a:p>
+            <a:pPr algn="r" indent="0" marL="0">
+              <a:buNone/>
+            </a:pPr>
+            <a:r>
+              <a:rPr lang="en-US" sz="1050" b="1" dirty="0">
+                <a:solidFill>
+                  <a:srgbClr val="FFFFFF"/>
+                </a:solidFill>
+                <a:latin typeface="맑은 고딕" pitchFamily="34" charset="0"/>
+                <a:ea typeface="맑은 고딕" pitchFamily="34" charset="-122"/>
+                <a:cs typeface="맑은 고딕" pitchFamily="34" charset="-120"/>
+              </a:rPr>
+              <a:t>240 h</a:t>
+            </a:r>
+            <a:endParaRPr lang="en-US" sz="1050" dirty="0"/>
+          </a:p>
+        </p:txBody>
+      </p:sp>
+      <p:sp>
+        <p:nvSpPr>
+          <p:cNvPr id="31" name="Shape 24"/>
+          <p:cNvSpPr/>
+          <p:nvPr/>
+        </p:nvSpPr>
+        <p:spPr>
+          <a:xfrm>
+            <a:off x="9199626" y="3657600"/>
+            <a:ext cx="1691640" cy="502920"/>
+          </a:xfrm>
+          <a:prstGeom prst="rect">
+            <a:avLst/>
+          </a:prstGeom>
+          <a:solidFill>
+            <a:srgbClr val="4C3C2C"/>
+          </a:solidFill>
+          <a:ln w="12700">
+            <a:solidFill>
+              <a:srgbClr val="D9DCE0"/>
+            </a:solidFill>
+            <a:prstDash val="solid"/>
+          </a:ln>
+        </p:spPr>
+      </p:sp>
+      <p:sp>
+        <p:nvSpPr>
+          <p:cNvPr id="32" name="Text 25"/>
+          <p:cNvSpPr txBox="1"/>
+          <p:nvPr/>
+        </p:nvSpPr>
+        <p:spPr>
+          <a:xfrm>
+            <a:off x="9199626" y="3657600"/>
+            <a:ext cx="1691640" cy="502920"/>
+          </a:xfrm>
+          <a:prstGeom prst="rect">
+            <a:avLst/>
+          </a:prstGeom>
+          <a:noFill/>
+          <a:ln/>
+        </p:spPr>
+        <p:txBody>
+          <a:bodyPr wrap="square" lIns="0" tIns="0" rIns="0" bIns="0" rtlCol="0" anchor="ctr"/>
+          <a:lstStyle/>
+          <a:p>
+            <a:pPr algn="ctr" indent="0" marL="0">
+              <a:buNone/>
+            </a:pPr>
+            <a:r>
+              <a:rPr lang="en-US" sz="1600" b="1" dirty="0">
+                <a:solidFill>
+                  <a:srgbClr val="FFFFFF"/>
+                </a:solidFill>
+                <a:latin typeface="맑은 고딕" pitchFamily="34" charset="0"/>
+                <a:ea typeface="맑은 고딕" pitchFamily="34" charset="-122"/>
+                <a:cs typeface="맑은 고딕" pitchFamily="34" charset="-120"/>
+              </a:rPr>
+              <a:t>b*  13.1</a:t>
+            </a:r>
+            <a:endParaRPr lang="en-US" sz="1600" dirty="0"/>
+          </a:p>
+        </p:txBody>
+      </p:sp>
+      <p:sp>
+        <p:nvSpPr>
+          <p:cNvPr id="33" name="Shape 26"/>
+          <p:cNvSpPr/>
+          <p:nvPr/>
+        </p:nvSpPr>
+        <p:spPr>
+          <a:xfrm>
+            <a:off x="9588246" y="4480560"/>
+            <a:ext cx="914400" cy="960120"/>
+          </a:xfrm>
+          <a:prstGeom prst="rect">
+            <a:avLst/>
+          </a:prstGeom>
+          <a:solidFill>
+            <a:srgbClr val="B23A2E"/>
+          </a:solidFill>
+          <a:ln w="12700">
+            <a:solidFill>
+              <a:srgbClr val="B23A2E"/>
+            </a:solidFill>
+            <a:prstDash val="solid"/>
+          </a:ln>
+        </p:spPr>
+      </p:sp>
+      <p:sp>
+        <p:nvSpPr>
+          <p:cNvPr id="34" name="Text 27"/>
+          <p:cNvSpPr txBox="1"/>
+          <p:nvPr/>
+        </p:nvSpPr>
+        <p:spPr>
+          <a:xfrm>
+            <a:off x="9131046" y="4169664"/>
+            <a:ext cx="1828800" cy="274320"/>
           </a:xfrm>
           <a:prstGeom prst="rect">
             <a:avLst/>
@@ -9230,19 +9567,19 @@
           <a:bodyPr wrap="square" lIns="0" tIns="0" rIns="0" bIns="0" rtlCol="0" anchor="t"/>
           <a:lstStyle/>
           <a:p>
-            <a:pPr marL="0" indent="0">
+            <a:pPr algn="ctr" indent="0" marL="0">
               <a:buNone/>
             </a:pPr>
             <a:r>
               <a:rPr lang="en-US" sz="1300" b="1" dirty="0">
                 <a:solidFill>
-                  <a:srgbClr val="3A6EA5"/>
-                </a:solidFill>
-                <a:latin typeface="맑은 고딕" pitchFamily="34" charset="0"/>
-                <a:ea typeface="맑은 고딕" pitchFamily="34" charset="-122"/>
-                <a:cs typeface="맑은 고딕" pitchFamily="34" charset="-120"/>
-              </a:rPr>
-              <a:t>위험도 낮음</a:t>
+                  <a:srgbClr val="B23A2E"/>
+                </a:solidFill>
+                <a:latin typeface="맑은 고딕" pitchFamily="34" charset="0"/>
+                <a:ea typeface="맑은 고딕" pitchFamily="34" charset="-122"/>
+                <a:cs typeface="맑은 고딕" pitchFamily="34" charset="-120"/>
+              </a:rPr>
+              <a:t>1.45 mm/년</a:t>
             </a:r>
             <a:endParaRPr lang="en-US" sz="1300" dirty="0"/>
           </a:p>
@@ -9250,14 +9587,37 @@
       </p:sp>
       <p:sp>
         <p:nvSpPr>
-          <p:cNvPr id="11" name="Text 8"/>
-          <p:cNvSpPr txBox="1"/>
-          <p:nvPr/>
-        </p:nvSpPr>
-        <p:spPr>
-          <a:xfrm>
-            <a:off x="3853637" y="3444569"/>
-            <a:ext cx="1097280" cy="274320"/>
+          <p:cNvPr id="35" name="Shape 28"/>
+          <p:cNvSpPr/>
+          <p:nvPr/>
+        </p:nvSpPr>
+        <p:spPr>
+          <a:xfrm>
+            <a:off x="2240280" y="5440680"/>
+            <a:ext cx="9219895" cy="0"/>
+          </a:xfrm>
+          <a:prstGeom prst="line">
+            <a:avLst/>
+          </a:prstGeom>
+          <a:noFill/>
+          <a:ln w="12700">
+            <a:solidFill>
+              <a:srgbClr val="A3A7AD"/>
+            </a:solidFill>
+            <a:prstDash val="solid"/>
+          </a:ln>
+        </p:spPr>
+      </p:sp>
+      <p:sp>
+        <p:nvSpPr>
+          <p:cNvPr id="36" name="Text 29"/>
+          <p:cNvSpPr txBox="1"/>
+          <p:nvPr/>
+        </p:nvSpPr>
+        <p:spPr>
+          <a:xfrm>
+            <a:off x="10454335" y="4434840"/>
+            <a:ext cx="1188720" cy="365760"/>
           </a:xfrm>
           <a:prstGeom prst="rect">
             <a:avLst/>
@@ -9269,50 +9629,11 @@
           <a:bodyPr wrap="square" lIns="0" tIns="0" rIns="0" bIns="0" rtlCol="0" anchor="t"/>
           <a:lstStyle/>
           <a:p>
-            <a:pPr marL="0" indent="0">
-              <a:buNone/>
-            </a:pPr>
-            <a:r>
-              <a:rPr lang="en-US" sz="1300" b="1" dirty="0">
-                <a:solidFill>
-                  <a:srgbClr val="3C8D5A"/>
-                </a:solidFill>
-                <a:latin typeface="맑은 고딕" pitchFamily="34" charset="0"/>
-                <a:ea typeface="맑은 고딕" pitchFamily="34" charset="-122"/>
-                <a:cs typeface="맑은 고딕" pitchFamily="34" charset="-120"/>
-              </a:rPr>
-              <a:t>중간</a:t>
-            </a:r>
-            <a:endParaRPr lang="en-US" sz="1300" dirty="0"/>
-          </a:p>
-        </p:txBody>
-      </p:sp>
-      <p:sp>
-        <p:nvSpPr>
-          <p:cNvPr id="12" name="Text 9"/>
-          <p:cNvSpPr txBox="1"/>
-          <p:nvPr/>
-        </p:nvSpPr>
-        <p:spPr>
-          <a:xfrm>
-            <a:off x="4396816" y="1980696"/>
-            <a:ext cx="1051560" cy="274320"/>
-          </a:xfrm>
-          <a:prstGeom prst="rect">
-            <a:avLst/>
-          </a:prstGeom>
-          <a:noFill/>
-          <a:ln/>
-        </p:spPr>
-        <p:txBody>
-          <a:bodyPr wrap="square" lIns="0" tIns="0" rIns="0" bIns="0" rtlCol="0" anchor="t"/>
-          <a:lstStyle/>
-          <a:p>
-            <a:pPr marL="0" indent="0" algn="r">
-              <a:buNone/>
-            </a:pPr>
-            <a:r>
-              <a:rPr lang="en-US" sz="1300" b="1" dirty="0">
+            <a:pPr algn="r" indent="0" marL="0">
+              <a:buNone/>
+            </a:pPr>
+            <a:r>
+              <a:rPr lang="en-US" sz="1800" b="1" dirty="0">
                 <a:solidFill>
                   <a:srgbClr val="B23A2E"/>
                 </a:solidFill>
@@ -9320,32 +9641,32 @@
                 <a:ea typeface="맑은 고딕" pitchFamily="34" charset="-122"/>
                 <a:cs typeface="맑은 고딕" pitchFamily="34" charset="-120"/>
               </a:rPr>
-              <a:t>높음</a:t>
-            </a:r>
-            <a:endParaRPr lang="en-US" sz="1300" dirty="0"/>
-          </a:p>
-        </p:txBody>
-      </p:sp>
-      <p:sp>
-        <p:nvSpPr>
-          <p:cNvPr id="13" name="Shape 10"/>
+              <a:t>약 4배</a:t>
+            </a:r>
+            <a:endParaRPr lang="en-US" sz="1800" dirty="0"/>
+          </a:p>
+        </p:txBody>
+      </p:sp>
+      <p:sp>
+        <p:nvSpPr>
+          <p:cNvPr id="37" name="Shape 30"/>
           <p:cNvSpPr/>
           <p:nvPr/>
         </p:nvSpPr>
         <p:spPr>
           <a:xfrm>
-            <a:off x="7452360" y="1417320"/>
-            <a:ext cx="4190695" cy="1051560"/>
+            <a:off x="548640" y="5623560"/>
+            <a:ext cx="3576218" cy="566928"/>
           </a:xfrm>
           <a:prstGeom prst="roundRect">
             <a:avLst>
-              <a:gd name="adj" fmla="val 6957"/>
+              <a:gd name="adj" fmla="val 12903"/>
             </a:avLst>
           </a:prstGeom>
           <a:solidFill>
             <a:srgbClr val="FBEDE4"/>
           </a:solidFill>
-          <a:ln w="6350">
+          <a:ln w="12700">
             <a:solidFill>
               <a:srgbClr val="FBEDE4"/>
             </a:solidFill>
@@ -9355,14 +9676,14 @@
       </p:sp>
       <p:sp>
         <p:nvSpPr>
-          <p:cNvPr id="14" name="Text 11"/>
-          <p:cNvSpPr txBox="1"/>
-          <p:nvPr/>
-        </p:nvSpPr>
-        <p:spPr>
-          <a:xfrm>
-            <a:off x="7726680" y="1508760"/>
-            <a:ext cx="3642055" cy="502920"/>
+          <p:cNvPr id="38" name="Text 31"/>
+          <p:cNvSpPr txBox="1"/>
+          <p:nvPr/>
+        </p:nvSpPr>
+        <p:spPr>
+          <a:xfrm>
+            <a:off x="777240" y="5623560"/>
+            <a:ext cx="3210458" cy="566928"/>
           </a:xfrm>
           <a:prstGeom prst="rect">
             <a:avLst/>
@@ -9374,11 +9695,11 @@
           <a:bodyPr wrap="square" lIns="0" tIns="0" rIns="0" bIns="0" rtlCol="0" anchor="ctr"/>
           <a:lstStyle/>
           <a:p>
-            <a:pPr marL="0" indent="0">
-              <a:buNone/>
-            </a:pPr>
-            <a:r>
-              <a:rPr lang="en-US" sz="2400" b="1" dirty="0">
+            <a:pPr indent="0" marL="0">
+              <a:buNone/>
+            </a:pPr>
+            <a:r>
+              <a:rPr lang="en-US" sz="1700" b="1" dirty="0">
                 <a:solidFill>
                   <a:srgbClr val="B5501F"/>
                 </a:solidFill>
@@ -9386,38 +9707,13 @@
                 <a:ea typeface="맑은 고딕" pitchFamily="34" charset="-122"/>
                 <a:cs typeface="맑은 고딕" pitchFamily="34" charset="-120"/>
               </a:rPr>
-              <a:t>ρ = 0.88</a:t>
-            </a:r>
-            <a:endParaRPr lang="en-US" sz="2400" dirty="0"/>
-          </a:p>
-        </p:txBody>
-      </p:sp>
-      <p:sp>
-        <p:nvSpPr>
-          <p:cNvPr id="15" name="Text 12"/>
-          <p:cNvSpPr txBox="1"/>
-          <p:nvPr/>
-        </p:nvSpPr>
-        <p:spPr>
-          <a:xfrm>
-            <a:off x="7726680" y="1993392"/>
-            <a:ext cx="3733495" cy="411480"/>
-          </a:xfrm>
-          <a:prstGeom prst="rect">
-            <a:avLst/>
-          </a:prstGeom>
-          <a:noFill/>
-          <a:ln/>
-        </p:spPr>
-        <p:txBody>
-          <a:bodyPr wrap="square" lIns="0" tIns="0" rIns="0" bIns="0" rtlCol="0" anchor="t"/>
-          <a:lstStyle/>
-          <a:p>
-            <a:pPr marL="0" indent="0">
-              <a:buNone/>
-            </a:pPr>
-            <a:r>
-              <a:rPr lang="en-US" sz="1200" dirty="0">
+              <a:t>ρ = 0.88   </a:t>
+            </a:r>
+            <a:pPr indent="0" marL="0">
+              <a:buNone/>
+            </a:pPr>
+            <a:r>
+              <a:rPr lang="en-US" sz="1150" dirty="0">
                 <a:solidFill>
                   <a:srgbClr val="6B6F76"/>
                 </a:solidFill>
@@ -9425,32 +9721,32 @@
                 <a:ea typeface="맑은 고딕" pitchFamily="34" charset="-122"/>
                 <a:cs typeface="맑은 고딕" pitchFamily="34" charset="-120"/>
               </a:rPr>
-              <a:t>b*와 부식 속도의 순위 상관 (p &lt; 0.002)</a:t>
-            </a:r>
-            <a:endParaRPr lang="en-US" sz="1200" dirty="0"/>
-          </a:p>
-        </p:txBody>
-      </p:sp>
-      <p:sp>
-        <p:nvSpPr>
-          <p:cNvPr id="16" name="Shape 13"/>
+              <a:t>색(b*)–부식 속도 상관</a:t>
+            </a:r>
+            <a:endParaRPr lang="en-US" sz="1400" dirty="0"/>
+          </a:p>
+        </p:txBody>
+      </p:sp>
+      <p:sp>
+        <p:nvSpPr>
+          <p:cNvPr id="39" name="Shape 32"/>
           <p:cNvSpPr/>
           <p:nvPr/>
         </p:nvSpPr>
         <p:spPr>
           <a:xfrm>
-            <a:off x="7452360" y="2606040"/>
-            <a:ext cx="4190695" cy="1051560"/>
+            <a:off x="4307738" y="5623560"/>
+            <a:ext cx="3576218" cy="566928"/>
           </a:xfrm>
           <a:prstGeom prst="roundRect">
             <a:avLst>
-              <a:gd name="adj" fmla="val 6957"/>
+              <a:gd name="adj" fmla="val 12903"/>
             </a:avLst>
           </a:prstGeom>
           <a:solidFill>
             <a:srgbClr val="F3F4F6"/>
           </a:solidFill>
-          <a:ln w="6350">
+          <a:ln w="12700">
             <a:solidFill>
               <a:srgbClr val="F3F4F6"/>
             </a:solidFill>
@@ -9460,14 +9756,14 @@
       </p:sp>
       <p:sp>
         <p:nvSpPr>
-          <p:cNvPr id="17" name="Text 14"/>
-          <p:cNvSpPr txBox="1"/>
-          <p:nvPr/>
-        </p:nvSpPr>
-        <p:spPr>
-          <a:xfrm>
-            <a:off x="7726680" y="2697480"/>
-            <a:ext cx="3642055" cy="502920"/>
+          <p:cNvPr id="40" name="Text 33"/>
+          <p:cNvSpPr txBox="1"/>
+          <p:nvPr/>
+        </p:nvSpPr>
+        <p:spPr>
+          <a:xfrm>
+            <a:off x="4536338" y="5623560"/>
+            <a:ext cx="3210458" cy="566928"/>
           </a:xfrm>
           <a:prstGeom prst="rect">
             <a:avLst/>
@@ -9479,11 +9775,11 @@
           <a:bodyPr wrap="square" lIns="0" tIns="0" rIns="0" bIns="0" rtlCol="0" anchor="ctr"/>
           <a:lstStyle/>
           <a:p>
-            <a:pPr marL="0" indent="0">
-              <a:buNone/>
-            </a:pPr>
-            <a:r>
-              <a:rPr lang="en-US" sz="2400" b="1" dirty="0">
+            <a:pPr indent="0" marL="0">
+              <a:buNone/>
+            </a:pPr>
+            <a:r>
+              <a:rPr lang="en-US" sz="1700" b="1" dirty="0">
                 <a:solidFill>
                   <a:srgbClr val="B5501F"/>
                 </a:solidFill>
@@ -9491,38 +9787,13 @@
                 <a:ea typeface="맑은 고딕" pitchFamily="34" charset="-122"/>
                 <a:cs typeface="맑은 고딕" pitchFamily="34" charset="-120"/>
               </a:rPr>
-              <a:t>3개 구간</a:t>
-            </a:r>
-            <a:endParaRPr lang="en-US" sz="2400" dirty="0"/>
-          </a:p>
-        </p:txBody>
-      </p:sp>
-      <p:sp>
-        <p:nvSpPr>
-          <p:cNvPr id="18" name="Text 15"/>
-          <p:cNvSpPr txBox="1"/>
-          <p:nvPr/>
-        </p:nvSpPr>
-        <p:spPr>
-          <a:xfrm>
-            <a:off x="7726680" y="3182112"/>
-            <a:ext cx="3733495" cy="411480"/>
-          </a:xfrm>
-          <a:prstGeom prst="rect">
-            <a:avLst/>
-          </a:prstGeom>
-          <a:noFill/>
-          <a:ln/>
-        </p:spPr>
-        <p:txBody>
-          <a:bodyPr wrap="square" lIns="0" tIns="0" rIns="0" bIns="0" rtlCol="0" anchor="t"/>
-          <a:lstStyle/>
-          <a:p>
-            <a:pPr marL="0" indent="0">
-              <a:buNone/>
-            </a:pPr>
-            <a:r>
-              <a:rPr lang="en-US" sz="1200" dirty="0">
+              <a:t>3개 구간   </a:t>
+            </a:r>
+            <a:pPr indent="0" marL="0">
+              <a:buNone/>
+            </a:pPr>
+            <a:r>
+              <a:rPr lang="en-US" sz="1150" dirty="0">
                 <a:solidFill>
                   <a:srgbClr val="6B6F76"/>
                 </a:solidFill>
@@ -9530,32 +9801,32 @@
                 <a:ea typeface="맑은 고딕" pitchFamily="34" charset="-122"/>
                 <a:cs typeface="맑은 고딕" pitchFamily="34" charset="-120"/>
               </a:rPr>
-              <a:t>단계별 부식 속도 구간이 서로 겹치지 않음</a:t>
-            </a:r>
-            <a:endParaRPr lang="en-US" sz="1200" dirty="0"/>
-          </a:p>
-        </p:txBody>
-      </p:sp>
-      <p:sp>
-        <p:nvSpPr>
-          <p:cNvPr id="19" name="Shape 16"/>
+              <a:t>위험도별 속도 구간 분리</a:t>
+            </a:r>
+            <a:endParaRPr lang="en-US" sz="1400" dirty="0"/>
+          </a:p>
+        </p:txBody>
+      </p:sp>
+      <p:sp>
+        <p:nvSpPr>
+          <p:cNvPr id="41" name="Shape 34"/>
           <p:cNvSpPr/>
           <p:nvPr/>
         </p:nvSpPr>
         <p:spPr>
           <a:xfrm>
-            <a:off x="7452360" y="3794760"/>
-            <a:ext cx="4190695" cy="1051560"/>
+            <a:off x="8066837" y="5623560"/>
+            <a:ext cx="3576218" cy="566928"/>
           </a:xfrm>
           <a:prstGeom prst="roundRect">
             <a:avLst>
-              <a:gd name="adj" fmla="val 6957"/>
+              <a:gd name="adj" fmla="val 12903"/>
             </a:avLst>
           </a:prstGeom>
           <a:solidFill>
             <a:srgbClr val="F3F4F6"/>
           </a:solidFill>
-          <a:ln w="6350">
+          <a:ln w="12700">
             <a:solidFill>
               <a:srgbClr val="F3F4F6"/>
             </a:solidFill>
@@ -9565,14 +9836,14 @@
       </p:sp>
       <p:sp>
         <p:nvSpPr>
-          <p:cNvPr id="20" name="Text 17"/>
-          <p:cNvSpPr txBox="1"/>
-          <p:nvPr/>
-        </p:nvSpPr>
-        <p:spPr>
-          <a:xfrm>
-            <a:off x="7726680" y="3886200"/>
-            <a:ext cx="3642055" cy="502920"/>
+          <p:cNvPr id="42" name="Text 35"/>
+          <p:cNvSpPr txBox="1"/>
+          <p:nvPr/>
+        </p:nvSpPr>
+        <p:spPr>
+          <a:xfrm>
+            <a:off x="8295437" y="5623560"/>
+            <a:ext cx="3210458" cy="566928"/>
           </a:xfrm>
           <a:prstGeom prst="rect">
             <a:avLst/>
@@ -9584,11 +9855,11 @@
           <a:bodyPr wrap="square" lIns="0" tIns="0" rIns="0" bIns="0" rtlCol="0" anchor="ctr"/>
           <a:lstStyle/>
           <a:p>
-            <a:pPr marL="0" indent="0">
-              <a:buNone/>
-            </a:pPr>
-            <a:r>
-              <a:rPr lang="en-US" sz="2400" b="1" dirty="0">
+            <a:pPr indent="0" marL="0">
+              <a:buNone/>
+            </a:pPr>
+            <a:r>
+              <a:rPr lang="en-US" sz="1700" b="1" dirty="0">
                 <a:solidFill>
                   <a:srgbClr val="B5501F"/>
                 </a:solidFill>
@@ -9596,22 +9867,36 @@
                 <a:ea typeface="맑은 고딕" pitchFamily="34" charset="-122"/>
                 <a:cs typeface="맑은 고딕" pitchFamily="34" charset="-120"/>
               </a:rPr>
-              <a:t>6가지 분석</a:t>
-            </a:r>
-            <a:endParaRPr lang="en-US" sz="2400" dirty="0"/>
-          </a:p>
-        </p:txBody>
-      </p:sp>
-      <p:sp>
-        <p:nvSpPr>
-          <p:cNvPr id="21" name="Text 18"/>
-          <p:cNvSpPr txBox="1"/>
-          <p:nvPr/>
-        </p:nvSpPr>
-        <p:spPr>
-          <a:xfrm>
-            <a:off x="7726680" y="4370832"/>
-            <a:ext cx="3733495" cy="411480"/>
+              <a:t>6가지 분석   </a:t>
+            </a:r>
+            <a:pPr indent="0" marL="0">
+              <a:buNone/>
+            </a:pPr>
+            <a:r>
+              <a:rPr lang="en-US" sz="1150" dirty="0">
+                <a:solidFill>
+                  <a:srgbClr val="6B6F76"/>
+                </a:solidFill>
+                <a:latin typeface="맑은 고딕" pitchFamily="34" charset="0"/>
+                <a:ea typeface="맑은 고딕" pitchFamily="34" charset="-122"/>
+                <a:cs typeface="맑은 고딕" pitchFamily="34" charset="-120"/>
+              </a:rPr>
+              <a:t>교차 검증 완료</a:t>
+            </a:r>
+            <a:endParaRPr lang="en-US" sz="1400" dirty="0"/>
+          </a:p>
+        </p:txBody>
+      </p:sp>
+      <p:sp>
+        <p:nvSpPr>
+          <p:cNvPr id="43" name="Text 36"/>
+          <p:cNvSpPr txBox="1"/>
+          <p:nvPr/>
+        </p:nvSpPr>
+        <p:spPr>
+          <a:xfrm>
+            <a:off x="7528255" y="1051560"/>
+            <a:ext cx="4114800" cy="228600"/>
           </a:xfrm>
           <a:prstGeom prst="rect">
             <a:avLst/>
@@ -9623,21 +9908,21 @@
           <a:bodyPr wrap="square" lIns="0" tIns="0" rIns="0" bIns="0" rtlCol="0" anchor="t"/>
           <a:lstStyle/>
           <a:p>
-            <a:pPr marL="0" indent="0">
-              <a:buNone/>
-            </a:pPr>
-            <a:r>
-              <a:rPr lang="en-US" sz="1200" dirty="0">
-                <a:solidFill>
-                  <a:srgbClr val="6B6F76"/>
-                </a:solidFill>
-                <a:latin typeface="맑은 고딕" pitchFamily="34" charset="0"/>
-                <a:ea typeface="맑은 고딕" pitchFamily="34" charset="-122"/>
-                <a:cs typeface="맑은 고딕" pitchFamily="34" charset="-120"/>
-              </a:rPr>
-              <a:t>SEM/EDS · XRD · 전기화학 · 3D 표면 · 녹 면적 · 색으로 교차 검증</a:t>
-            </a:r>
-            <a:endParaRPr lang="en-US" sz="1200" dirty="0"/>
+            <a:pPr algn="r" indent="0" marL="0">
+              <a:buNone/>
+            </a:pPr>
+            <a:r>
+              <a:rPr lang="en-US" sz="1000" i="1" dirty="0">
+                <a:solidFill>
+                  <a:srgbClr val="A3A7AD"/>
+                </a:solidFill>
+                <a:latin typeface="맑은 고딕" pitchFamily="34" charset="0"/>
+                <a:ea typeface="맑은 고딕" pitchFamily="34" charset="-122"/>
+                <a:cs typeface="맑은 고딕" pitchFamily="34" charset="-120"/>
+              </a:rPr>
+              <a:t>탄소강 · 240시간 촉진부식 · 단계별 평균값</a:t>
+            </a:r>
+            <a:endParaRPr lang="en-US" sz="1000" dirty="0"/>
           </a:p>
         </p:txBody>
       </p:sp>
@@ -11251,13 +11536,12 @@
 
 <file path=ppt/slides/slide9.xml><?xml version="1.0" encoding="utf-8"?>
 <p:sld xmlns:a="http://schemas.openxmlformats.org/drawingml/2006/main" xmlns:r="http://schemas.openxmlformats.org/officeDocument/2006/relationships" xmlns:p="http://schemas.openxmlformats.org/presentationml/2006/main">
-  <p:cSld name="Slide 8">
+  <p:cSld name="Slide 3">
     <p:bg>
       <p:bgPr>
         <a:solidFill>
           <a:srgbClr val="FFFFFF"/>
         </a:solidFill>
-        <a:effectLst/>
       </p:bgPr>
     </p:bg>
     <p:spTree>
@@ -11295,11 +11579,11 @@
           <a:bodyPr wrap="square" lIns="0" tIns="0" rIns="0" bIns="0" rtlCol="0" anchor="t"/>
           <a:lstStyle/>
           <a:p>
-            <a:pPr marL="0" indent="0">
-              <a:buNone/>
-            </a:pPr>
-            <a:r>
-              <a:rPr lang="en-US" sz="1200" b="1" kern="0" spc="100" dirty="0">
+            <a:pPr indent="0" marL="0">
+              <a:buNone/>
+            </a:pPr>
+            <a:r>
+              <a:rPr lang="en-US" sz="1200" b="1" spc="100" kern="0" dirty="0">
                 <a:solidFill>
                   <a:srgbClr val="B5501F"/>
                 </a:solidFill>
@@ -11334,7 +11618,7 @@
           <a:bodyPr wrap="square" lIns="0" tIns="0" rIns="0" bIns="0" rtlCol="0" anchor="ctr"/>
           <a:lstStyle/>
           <a:p>
-            <a:pPr marL="0" indent="0">
+            <a:pPr indent="0" marL="0">
               <a:buNone/>
             </a:pPr>
             <a:r>
@@ -11373,7 +11657,7 @@
           <a:bodyPr wrap="square" lIns="0" tIns="0" rIns="0" bIns="0" rtlCol="0" anchor="t"/>
           <a:lstStyle/>
           <a:p>
-            <a:pPr marL="0" indent="0">
+            <a:pPr indent="0" marL="0">
               <a:buNone/>
             </a:pPr>
             <a:r>
@@ -11385,29 +11669,7 @@
                 <a:ea typeface="맑은 고딕" pitchFamily="34" charset="-122"/>
                 <a:cs typeface="맑은 고딕" pitchFamily="34" charset="-120"/>
               </a:rPr>
-              <a:t>MLC  ·  </a:t>
-            </a:r>
-            <a:r>
-              <a:rPr lang="en-US" sz="900" dirty="0" err="1">
-                <a:solidFill>
-                  <a:srgbClr val="A3A7AD"/>
-                </a:solidFill>
-                <a:latin typeface="맑은 고딕" pitchFamily="34" charset="0"/>
-                <a:ea typeface="맑은 고딕" pitchFamily="34" charset="-122"/>
-                <a:cs typeface="맑은 고딕" pitchFamily="34" charset="-120"/>
-              </a:rPr>
-              <a:t>제주</a:t>
-            </a:r>
-            <a:r>
-              <a:rPr lang="en-US" sz="900" dirty="0">
-                <a:solidFill>
-                  <a:srgbClr val="A3A7AD"/>
-                </a:solidFill>
-                <a:latin typeface="맑은 고딕" pitchFamily="34" charset="0"/>
-                <a:ea typeface="맑은 고딕" pitchFamily="34" charset="-122"/>
-                <a:cs typeface="맑은 고딕" pitchFamily="34" charset="-120"/>
-              </a:rPr>
-              <a:t> A-STREAM 2026</a:t>
+              <a:t>MLC  ·  제주 A-STREAM 2026</a:t>
             </a:r>
             <a:endParaRPr lang="en-US" sz="900" dirty="0"/>
           </a:p>
@@ -11434,7 +11696,7 @@
           <a:bodyPr wrap="square" lIns="0" tIns="0" rIns="0" bIns="0" rtlCol="0" anchor="t"/>
           <a:lstStyle/>
           <a:p>
-            <a:pPr marL="0" indent="0" algn="r">
+            <a:pPr algn="r" indent="0" marL="0">
               <a:buNone/>
             </a:pPr>
             <a:r>
@@ -11471,7 +11733,7 @@
           <a:solidFill>
             <a:srgbClr val="F3F4F6"/>
           </a:solidFill>
-          <a:ln w="6350">
+          <a:ln w="12700">
             <a:solidFill>
               <a:srgbClr val="F3F4F6"/>
             </a:solidFill>
@@ -11500,7 +11762,7 @@
           <a:bodyPr wrap="square" lIns="0" tIns="0" rIns="0" bIns="0" rtlCol="0" anchor="t"/>
           <a:lstStyle/>
           <a:p>
-            <a:pPr marL="0" indent="0">
+            <a:pPr indent="0" marL="0">
               <a:buNone/>
             </a:pPr>
             <a:r>
@@ -11539,7 +11801,7 @@
           <a:bodyPr wrap="square" lIns="0" tIns="0" rIns="0" bIns="0" rtlCol="0" anchor="t"/>
           <a:lstStyle/>
           <a:p>
-            <a:pPr marL="0" indent="0" algn="r">
+            <a:pPr algn="r" indent="0" marL="0">
               <a:buNone/>
             </a:pPr>
             <a:r>
@@ -11578,7 +11840,7 @@
           <a:bodyPr wrap="square" lIns="0" tIns="0" rIns="0" bIns="0" rtlCol="0" anchor="t"/>
           <a:lstStyle/>
           <a:p>
-            <a:pPr marL="0" indent="0">
+            <a:pPr indent="0" marL="0">
               <a:buNone/>
             </a:pPr>
             <a:r>
@@ -11617,7 +11879,7 @@
           <a:bodyPr wrap="square" lIns="0" tIns="0" rIns="0" bIns="0" rtlCol="0" anchor="t"/>
           <a:lstStyle/>
           <a:p>
-            <a:pPr marL="0" indent="0">
+            <a:pPr indent="0" marL="0">
               <a:buNone/>
             </a:pPr>
             <a:r>
@@ -11654,7 +11916,7 @@
           <a:solidFill>
             <a:srgbClr val="F3F4F6"/>
           </a:solidFill>
-          <a:ln w="6350">
+          <a:ln w="12700">
             <a:solidFill>
               <a:srgbClr val="F3F4F6"/>
             </a:solidFill>
@@ -11683,7 +11945,7 @@
           <a:bodyPr wrap="square" lIns="0" tIns="0" rIns="0" bIns="0" rtlCol="0" anchor="t"/>
           <a:lstStyle/>
           <a:p>
-            <a:pPr marL="0" indent="0">
+            <a:pPr indent="0" marL="0">
               <a:buNone/>
             </a:pPr>
             <a:r>
@@ -11722,7 +11984,7 @@
           <a:bodyPr wrap="square" lIns="0" tIns="0" rIns="0" bIns="0" rtlCol="0" anchor="t"/>
           <a:lstStyle/>
           <a:p>
-            <a:pPr marL="0" indent="0" algn="r">
+            <a:pPr algn="r" indent="0" marL="0">
               <a:buNone/>
             </a:pPr>
             <a:r>
@@ -11761,7 +12023,7 @@
           <a:bodyPr wrap="square" lIns="0" tIns="0" rIns="0" bIns="0" rtlCol="0" anchor="t"/>
           <a:lstStyle/>
           <a:p>
-            <a:pPr marL="0" indent="0">
+            <a:pPr indent="0" marL="0">
               <a:buNone/>
             </a:pPr>
             <a:r>
@@ -11800,7 +12062,7 @@
           <a:bodyPr wrap="square" lIns="0" tIns="0" rIns="0" bIns="0" rtlCol="0" anchor="t"/>
           <a:lstStyle/>
           <a:p>
-            <a:pPr marL="0" indent="0">
+            <a:pPr indent="0" marL="0">
               <a:buNone/>
             </a:pPr>
             <a:r>
@@ -11837,7 +12099,7 @@
           <a:solidFill>
             <a:srgbClr val="F3F4F6"/>
           </a:solidFill>
-          <a:ln w="6350">
+          <a:ln w="12700">
             <a:solidFill>
               <a:srgbClr val="F3F4F6"/>
             </a:solidFill>
@@ -11866,7 +12128,7 @@
           <a:bodyPr wrap="square" lIns="0" tIns="0" rIns="0" bIns="0" rtlCol="0" anchor="t"/>
           <a:lstStyle/>
           <a:p>
-            <a:pPr marL="0" indent="0">
+            <a:pPr indent="0" marL="0">
               <a:buNone/>
             </a:pPr>
             <a:r>
@@ -11905,7 +12167,7 @@
           <a:bodyPr wrap="square" lIns="0" tIns="0" rIns="0" bIns="0" rtlCol="0" anchor="t"/>
           <a:lstStyle/>
           <a:p>
-            <a:pPr marL="0" indent="0" algn="r">
+            <a:pPr algn="r" indent="0" marL="0">
               <a:buNone/>
             </a:pPr>
             <a:r>
@@ -11944,7 +12206,7 @@
           <a:bodyPr wrap="square" lIns="0" tIns="0" rIns="0" bIns="0" rtlCol="0" anchor="t"/>
           <a:lstStyle/>
           <a:p>
-            <a:pPr marL="0" indent="0">
+            <a:pPr indent="0" marL="0">
               <a:buNone/>
             </a:pPr>
             <a:r>
@@ -11983,7 +12245,7 @@
           <a:bodyPr wrap="square" lIns="0" tIns="0" rIns="0" bIns="0" rtlCol="0" anchor="t"/>
           <a:lstStyle/>
           <a:p>
-            <a:pPr marL="0" indent="0">
+            <a:pPr indent="0" marL="0">
               <a:buNone/>
             </a:pPr>
             <a:r>
@@ -12022,7 +12284,7 @@
           <a:bodyPr wrap="square" lIns="0" tIns="0" rIns="0" bIns="0" rtlCol="0" anchor="t"/>
           <a:lstStyle/>
           <a:p>
-            <a:pPr marL="0" indent="0">
+            <a:pPr indent="0" marL="0">
               <a:buNone/>
             </a:pPr>
             <a:r>
@@ -12088,7 +12350,7 @@
           <a:bodyPr wrap="square" lIns="0" tIns="0" rIns="0" bIns="0" rtlCol="0" anchor="ctr"/>
           <a:lstStyle/>
           <a:p>
-            <a:pPr marL="0" indent="0" algn="ctr">
+            <a:pPr algn="ctr" indent="0" marL="0">
               <a:buNone/>
             </a:pPr>
             <a:r>
@@ -12154,7 +12416,7 @@
           <a:bodyPr wrap="square" lIns="0" tIns="0" rIns="0" bIns="0" rtlCol="0" anchor="ctr"/>
           <a:lstStyle/>
           <a:p>
-            <a:pPr marL="0" indent="0" algn="ctr">
+            <a:pPr algn="ctr" indent="0" marL="0">
               <a:buNone/>
             </a:pPr>
             <a:r>
@@ -12220,7 +12482,7 @@
           <a:bodyPr wrap="square" lIns="0" tIns="0" rIns="0" bIns="0" rtlCol="0" anchor="ctr"/>
           <a:lstStyle/>
           <a:p>
-            <a:pPr marL="0" indent="0" algn="ctr">
+            <a:pPr algn="ctr" indent="0" marL="0">
               <a:buNone/>
             </a:pPr>
             <a:r>
@@ -12286,7 +12548,7 @@
           <a:bodyPr wrap="square" lIns="0" tIns="0" rIns="0" bIns="0" rtlCol="0" anchor="ctr"/>
           <a:lstStyle/>
           <a:p>
-            <a:pPr marL="0" indent="0" algn="ctr">
+            <a:pPr algn="ctr" indent="0" marL="0">
               <a:buNone/>
             </a:pPr>
             <a:r>
@@ -12306,106 +12568,106 @@
       </p:sp>
       <p:sp>
         <p:nvSpPr>
-          <p:cNvPr id="30" name="Text 28"/>
-          <p:cNvSpPr txBox="1"/>
-          <p:nvPr/>
-        </p:nvSpPr>
-        <p:spPr>
-          <a:xfrm>
-            <a:off x="548640" y="3749040"/>
-            <a:ext cx="822960" cy="475488"/>
-          </a:xfrm>
-          <a:prstGeom prst="rect">
-            <a:avLst/>
-          </a:prstGeom>
-          <a:noFill/>
-          <a:ln/>
-        </p:spPr>
-        <p:txBody>
-          <a:bodyPr wrap="square" lIns="0" tIns="0" rIns="0" bIns="0" rtlCol="0" anchor="ctr"/>
-          <a:lstStyle/>
-          <a:p>
-            <a:pPr marL="0" indent="0">
-              <a:buNone/>
-            </a:pPr>
-            <a:r>
-              <a:rPr lang="en-US" sz="1600" b="1" dirty="0">
-                <a:solidFill>
-                  <a:srgbClr val="B5501F"/>
-                </a:solidFill>
-                <a:latin typeface="맑은 고딕" pitchFamily="34" charset="0"/>
-                <a:ea typeface="맑은 고딕" pitchFamily="34" charset="-122"/>
-                <a:cs typeface="맑은 고딕" pitchFamily="34" charset="-120"/>
-              </a:rPr>
-              <a:t>TAM</a:t>
-            </a:r>
-            <a:endParaRPr lang="en-US" sz="1600" dirty="0"/>
-          </a:p>
-        </p:txBody>
-      </p:sp>
-      <p:sp>
-        <p:nvSpPr>
-          <p:cNvPr id="31" name="Shape 29"/>
+          <p:cNvPr id="30" name="Shape 28"/>
           <p:cNvSpPr/>
           <p:nvPr/>
         </p:nvSpPr>
         <p:spPr>
           <a:xfrm>
-            <a:off x="1417320" y="3749040"/>
-            <a:ext cx="6583680" cy="475488"/>
+            <a:off x="548640" y="3703320"/>
+            <a:ext cx="3017520" cy="2377440"/>
           </a:xfrm>
           <a:prstGeom prst="roundRect">
             <a:avLst>
-              <a:gd name="adj" fmla="val 11538"/>
+              <a:gd name="adj" fmla="val 3077"/>
             </a:avLst>
           </a:prstGeom>
           <a:solidFill>
-            <a:srgbClr val="FFF6DB"/>
+            <a:srgbClr val="FBEDE4"/>
           </a:solidFill>
-          <a:ln w="15875">
+          <a:ln w="12700">
             <a:solidFill>
-              <a:srgbClr val="E0B23C"/>
+              <a:srgbClr val="FBEDE4"/>
             </a:solidFill>
-            <a:prstDash val="dash"/>
+            <a:prstDash val="solid"/>
           </a:ln>
         </p:spPr>
       </p:sp>
       <p:sp>
         <p:nvSpPr>
+          <p:cNvPr id="31" name="Text 29"/>
+          <p:cNvSpPr txBox="1"/>
+          <p:nvPr/>
+        </p:nvSpPr>
+        <p:spPr>
+          <a:xfrm>
+            <a:off x="822960" y="3931920"/>
+            <a:ext cx="2560320" cy="868680"/>
+          </a:xfrm>
+          <a:prstGeom prst="rect">
+            <a:avLst/>
+          </a:prstGeom>
+          <a:noFill/>
+          <a:ln/>
+        </p:spPr>
+        <p:txBody>
+          <a:bodyPr wrap="square" lIns="0" tIns="0" rIns="0" bIns="0" rtlCol="0" anchor="ctr"/>
+          <a:lstStyle/>
+          <a:p>
+            <a:pPr indent="0" marL="0">
+              <a:buNone/>
+            </a:pPr>
+            <a:r>
+              <a:rPr lang="en-US" sz="4400" b="1" dirty="0">
+                <a:solidFill>
+                  <a:srgbClr val="B5501F"/>
+                </a:solidFill>
+                <a:latin typeface="맑은 고딕" pitchFamily="34" charset="0"/>
+                <a:ea typeface="맑은 고딕" pitchFamily="34" charset="-122"/>
+                <a:cs typeface="맑은 고딕" pitchFamily="34" charset="-120"/>
+              </a:rPr>
+              <a:t>371곳</a:t>
+            </a:r>
+            <a:endParaRPr lang="en-US" sz="4400" dirty="0"/>
+          </a:p>
+        </p:txBody>
+      </p:sp>
+      <p:sp>
+        <p:nvSpPr>
           <p:cNvPr id="32" name="Text 30"/>
           <p:cNvSpPr txBox="1"/>
           <p:nvPr/>
         </p:nvSpPr>
         <p:spPr>
           <a:xfrm>
-            <a:off x="1554480" y="3749040"/>
-            <a:ext cx="6309360" cy="475488"/>
-          </a:xfrm>
-          <a:prstGeom prst="rect">
-            <a:avLst/>
-          </a:prstGeom>
-          <a:noFill/>
-          <a:ln/>
-        </p:spPr>
-        <p:txBody>
-          <a:bodyPr wrap="square" lIns="0" tIns="0" rIns="0" bIns="0" rtlCol="0" anchor="ctr"/>
-          <a:lstStyle/>
-          <a:p>
-            <a:pPr marL="0" indent="0">
-              <a:buNone/>
-            </a:pPr>
-            <a:r>
-              <a:rPr lang="en-US" sz="1150" dirty="0">
-                <a:solidFill>
-                  <a:srgbClr val="9A6A00"/>
-                </a:solidFill>
-                <a:latin typeface="맑은 고딕" pitchFamily="34" charset="0"/>
-                <a:ea typeface="맑은 고딕" pitchFamily="34" charset="-122"/>
-                <a:cs typeface="맑은 고딕" pitchFamily="34" charset="-120"/>
-              </a:rPr>
-              <a:t>✎  글로벌 부식 모니터링 시장 — USD 1.1–2.9B (2025, 보고서별 상이): 1개 확정</a:t>
-            </a:r>
-            <a:endParaRPr lang="en-US" sz="1150" dirty="0"/>
+            <a:off x="822960" y="4846320"/>
+            <a:ext cx="2560320" cy="320040"/>
+          </a:xfrm>
+          <a:prstGeom prst="rect">
+            <a:avLst/>
+          </a:prstGeom>
+          <a:noFill/>
+          <a:ln/>
+        </p:spPr>
+        <p:txBody>
+          <a:bodyPr wrap="square" lIns="0" tIns="0" rIns="0" bIns="0" rtlCol="0" anchor="t"/>
+          <a:lstStyle/>
+          <a:p>
+            <a:pPr indent="0" marL="0">
+              <a:buNone/>
+            </a:pPr>
+            <a:r>
+              <a:rPr lang="en-US" sz="1450" b="1" dirty="0">
+                <a:solidFill>
+                  <a:srgbClr val="2B2D31"/>
+                </a:solidFill>
+                <a:latin typeface="맑은 고딕" pitchFamily="34" charset="0"/>
+                <a:ea typeface="맑은 고딕" pitchFamily="34" charset="-122"/>
+                <a:cs typeface="맑은 고딕" pitchFamily="34" charset="-120"/>
+              </a:rPr>
+              <a:t>멕시코만 유인 생산 플랫폼</a:t>
+            </a:r>
+            <a:endParaRPr lang="en-US" sz="1450" dirty="0"/>
           </a:p>
         </p:txBody>
       </p:sp>
@@ -12417,139 +12679,156 @@
         </p:nvSpPr>
         <p:spPr>
           <a:xfrm>
-            <a:off x="548640" y="4315968"/>
-            <a:ext cx="822960" cy="475488"/>
-          </a:xfrm>
-          <a:prstGeom prst="rect">
-            <a:avLst/>
-          </a:prstGeom>
-          <a:noFill/>
-          <a:ln/>
-        </p:spPr>
-        <p:txBody>
-          <a:bodyPr wrap="square" lIns="0" tIns="0" rIns="0" bIns="0" rtlCol="0" anchor="ctr"/>
-          <a:lstStyle/>
-          <a:p>
-            <a:pPr marL="0" indent="0">
-              <a:buNone/>
-            </a:pPr>
-            <a:r>
-              <a:rPr lang="en-US" sz="1600" b="1" dirty="0">
-                <a:solidFill>
-                  <a:srgbClr val="B5501F"/>
-                </a:solidFill>
-                <a:latin typeface="맑은 고딕" pitchFamily="34" charset="0"/>
-                <a:ea typeface="맑은 고딕" pitchFamily="34" charset="-122"/>
-                <a:cs typeface="맑은 고딕" pitchFamily="34" charset="-120"/>
-              </a:rPr>
-              <a:t>SAM</a:t>
-            </a:r>
-            <a:endParaRPr lang="en-US" sz="1600" dirty="0"/>
-          </a:p>
-        </p:txBody>
-      </p:sp>
-      <p:sp>
-        <p:nvSpPr>
-          <p:cNvPr id="34" name="Shape 32"/>
+            <a:off x="822960" y="5184648"/>
+            <a:ext cx="2560320" cy="548640"/>
+          </a:xfrm>
+          <a:prstGeom prst="rect">
+            <a:avLst/>
+          </a:prstGeom>
+          <a:noFill/>
+          <a:ln/>
+        </p:spPr>
+        <p:txBody>
+          <a:bodyPr wrap="square" lIns="0" tIns="0" rIns="0" bIns="0" rtlCol="0" anchor="t"/>
+          <a:lstStyle/>
+          <a:p>
+            <a:pPr indent="0" marL="0">
+              <a:buNone/>
+            </a:pPr>
+            <a:r>
+              <a:rPr lang="en-US" sz="1250" dirty="0">
+                <a:solidFill>
+                  <a:srgbClr val="6B6F76"/>
+                </a:solidFill>
+                <a:latin typeface="맑은 고딕" pitchFamily="34" charset="0"/>
+                <a:ea typeface="맑은 고딕" pitchFamily="34" charset="-122"/>
+                <a:cs typeface="맑은 고딕" pitchFamily="34" charset="-120"/>
+              </a:rPr>
+              <a:t>매년 Level I 점검이 돌아오는</a:t>
+            </a:r>
+            <a:endParaRPr lang="en-US" sz="1250" dirty="0"/>
+          </a:p>
+          <a:p>
+            <a:pPr indent="0" marL="0">
+              <a:buNone/>
+            </a:pPr>
+            <a:r>
+              <a:rPr lang="en-US" sz="1250" dirty="0">
+                <a:solidFill>
+                  <a:srgbClr val="6B6F76"/>
+                </a:solidFill>
+                <a:latin typeface="맑은 고딕" pitchFamily="34" charset="0"/>
+                <a:ea typeface="맑은 고딕" pitchFamily="34" charset="-122"/>
+                <a:cs typeface="맑은 고딕" pitchFamily="34" charset="-120"/>
+              </a:rPr>
+              <a:t>첫 타깃 시장</a:t>
+            </a:r>
+            <a:endParaRPr lang="en-US" sz="1250" dirty="0"/>
+          </a:p>
+        </p:txBody>
+      </p:sp>
+      <p:sp>
+        <p:nvSpPr>
+          <p:cNvPr id="34" name="Text 32"/>
+          <p:cNvSpPr txBox="1"/>
+          <p:nvPr/>
+        </p:nvSpPr>
+        <p:spPr>
+          <a:xfrm>
+            <a:off x="822960" y="5733288"/>
+            <a:ext cx="2560320" cy="228600"/>
+          </a:xfrm>
+          <a:prstGeom prst="rect">
+            <a:avLst/>
+          </a:prstGeom>
+          <a:noFill/>
+          <a:ln/>
+        </p:spPr>
+        <p:txBody>
+          <a:bodyPr wrap="square" lIns="0" tIns="0" rIns="0" bIns="0" rtlCol="0" anchor="t"/>
+          <a:lstStyle/>
+          <a:p>
+            <a:pPr indent="0" marL="0">
+              <a:buNone/>
+            </a:pPr>
+            <a:r>
+              <a:rPr lang="en-US" sz="1000" i="1" dirty="0">
+                <a:solidFill>
+                  <a:srgbClr val="A3A7AD"/>
+                </a:solidFill>
+                <a:latin typeface="맑은 고딕" pitchFamily="34" charset="0"/>
+                <a:ea typeface="맑은 고딕" pitchFamily="34" charset="-122"/>
+                <a:cs typeface="맑은 고딕" pitchFamily="34" charset="-120"/>
+              </a:rPr>
+              <a:t>BSEE, 2024.9</a:t>
+            </a:r>
+            <a:endParaRPr lang="en-US" sz="1000" dirty="0"/>
+          </a:p>
+        </p:txBody>
+      </p:sp>
+      <p:sp>
+        <p:nvSpPr>
+          <p:cNvPr id="35" name="Shape 33"/>
           <p:cNvSpPr/>
           <p:nvPr/>
         </p:nvSpPr>
         <p:spPr>
           <a:xfrm>
-            <a:off x="1417320" y="4315968"/>
-            <a:ext cx="6583680" cy="475488"/>
+            <a:off x="3840480" y="3703320"/>
+            <a:ext cx="3840480" cy="2377440"/>
           </a:xfrm>
           <a:prstGeom prst="roundRect">
             <a:avLst>
-              <a:gd name="adj" fmla="val 11538"/>
+              <a:gd name="adj" fmla="val 3077"/>
             </a:avLst>
           </a:prstGeom>
           <a:solidFill>
-            <a:srgbClr val="FFF6DB"/>
+            <a:srgbClr val="F3F4F6"/>
           </a:solidFill>
-          <a:ln w="15875">
+          <a:ln w="12700">
             <a:solidFill>
-              <a:srgbClr val="E0B23C"/>
+              <a:srgbClr val="F3F4F6"/>
             </a:solidFill>
-            <a:prstDash val="dash"/>
+            <a:prstDash val="solid"/>
           </a:ln>
         </p:spPr>
       </p:sp>
       <p:sp>
         <p:nvSpPr>
-          <p:cNvPr id="35" name="Text 33"/>
-          <p:cNvSpPr txBox="1"/>
-          <p:nvPr/>
-        </p:nvSpPr>
-        <p:spPr>
-          <a:xfrm>
-            <a:off x="1554480" y="4315968"/>
-            <a:ext cx="6309360" cy="475488"/>
-          </a:xfrm>
-          <a:prstGeom prst="rect">
-            <a:avLst/>
-          </a:prstGeom>
-          <a:noFill/>
-          <a:ln/>
-        </p:spPr>
-        <p:txBody>
-          <a:bodyPr wrap="square" lIns="0" tIns="0" rIns="0" bIns="0" rtlCol="0" anchor="ctr"/>
-          <a:lstStyle/>
-          <a:p>
-            <a:pPr marL="0" indent="0">
-              <a:buNone/>
-            </a:pPr>
-            <a:r>
-              <a:rPr lang="en-US" sz="1150" dirty="0">
-                <a:solidFill>
-                  <a:srgbClr val="9A6A00"/>
-                </a:solidFill>
-                <a:latin typeface="맑은 고딕" pitchFamily="34" charset="0"/>
-                <a:ea typeface="맑은 고딕" pitchFamily="34" charset="-122"/>
-                <a:cs typeface="맑은 고딕" pitchFamily="34" charset="-120"/>
-              </a:rPr>
-              <a:t>✎  미국 멕시코만 해양 플랫폼 · 미드스트림 외부 부식 점검 시장</a:t>
-            </a:r>
-            <a:endParaRPr lang="en-US" sz="1150" dirty="0"/>
-          </a:p>
-        </p:txBody>
-      </p:sp>
-      <p:sp>
-        <p:nvSpPr>
           <p:cNvPr id="36" name="Text 34"/>
           <p:cNvSpPr txBox="1"/>
           <p:nvPr/>
         </p:nvSpPr>
         <p:spPr>
           <a:xfrm>
-            <a:off x="548640" y="4882896"/>
-            <a:ext cx="822960" cy="475488"/>
-          </a:xfrm>
-          <a:prstGeom prst="rect">
-            <a:avLst/>
-          </a:prstGeom>
-          <a:noFill/>
-          <a:ln/>
-        </p:spPr>
-        <p:txBody>
-          <a:bodyPr wrap="square" lIns="0" tIns="0" rIns="0" bIns="0" rtlCol="0" anchor="ctr"/>
-          <a:lstStyle/>
-          <a:p>
-            <a:pPr marL="0" indent="0">
-              <a:buNone/>
-            </a:pPr>
-            <a:r>
-              <a:rPr lang="en-US" sz="1600" b="1" dirty="0">
-                <a:solidFill>
-                  <a:srgbClr val="B5501F"/>
-                </a:solidFill>
-                <a:latin typeface="맑은 고딕" pitchFamily="34" charset="0"/>
-                <a:ea typeface="맑은 고딕" pitchFamily="34" charset="-122"/>
-                <a:cs typeface="맑은 고딕" pitchFamily="34" charset="-120"/>
-              </a:rPr>
-              <a:t>SOM</a:t>
-            </a:r>
-            <a:endParaRPr lang="en-US" sz="1600" dirty="0"/>
+            <a:off x="4114800" y="3886200"/>
+            <a:ext cx="3383280" cy="292608"/>
+          </a:xfrm>
+          <a:prstGeom prst="rect">
+            <a:avLst/>
+          </a:prstGeom>
+          <a:noFill/>
+          <a:ln/>
+        </p:spPr>
+        <p:txBody>
+          <a:bodyPr wrap="square" lIns="0" tIns="0" rIns="0" bIns="0" rtlCol="0" anchor="t"/>
+          <a:lstStyle/>
+          <a:p>
+            <a:pPr indent="0" marL="0">
+              <a:buNone/>
+            </a:pPr>
+            <a:r>
+              <a:rPr lang="en-US" sz="1300" b="1" dirty="0">
+                <a:solidFill>
+                  <a:srgbClr val="1F5F7A"/>
+                </a:solidFill>
+                <a:latin typeface="맑은 고딕" pitchFamily="34" charset="0"/>
+                <a:ea typeface="맑은 고딕" pitchFamily="34" charset="-122"/>
+                <a:cs typeface="맑은 고딕" pitchFamily="34" charset="-120"/>
+              </a:rPr>
+              <a:t>구매를 움직이는 3가지 동기</a:t>
+            </a:r>
+            <a:endParaRPr lang="en-US" sz="1300" dirty="0"/>
           </a:p>
         </p:txBody>
       </p:sp>
@@ -12561,84 +12840,324 @@
         </p:nvSpPr>
         <p:spPr>
           <a:xfrm>
-            <a:off x="1417320" y="4882896"/>
-            <a:ext cx="6583680" cy="475488"/>
+            <a:off x="4114800" y="4297680"/>
+            <a:ext cx="420624" cy="420624"/>
+          </a:xfrm>
+          <a:prstGeom prst="ellipse">
+            <a:avLst/>
+          </a:prstGeom>
+          <a:solidFill>
+            <a:srgbClr val="2B2D31"/>
+          </a:solidFill>
+          <a:ln w="12700">
+            <a:solidFill>
+              <a:srgbClr val="2B2D31"/>
+            </a:solidFill>
+            <a:prstDash val="solid"/>
+          </a:ln>
+        </p:spPr>
+      </p:sp>
+      <p:pic>
+        <p:nvPicPr>
+          <p:cNvPr id="38" name="Image 0" descr="preencoded.png">    </p:cNvPr>
+          <p:cNvPicPr>
+            <a:picLocks noChangeAspect="1"/>
+          </p:cNvPicPr>
+          <p:nvPr/>
+        </p:nvPicPr>
+        <p:blipFill>
+          <a:blip r:embed="rId1"/>
+          <a:stretch>
+            <a:fillRect/>
+          </a:stretch>
+        </p:blipFill>
+        <p:spPr>
+          <a:xfrm>
+            <a:off x="4224162" y="4407042"/>
+            <a:ext cx="201900" cy="201900"/>
+          </a:xfrm>
+          <a:prstGeom prst="rect">
+            <a:avLst/>
+          </a:prstGeom>
+        </p:spPr>
+      </p:pic>
+      <p:sp>
+        <p:nvSpPr>
+          <p:cNvPr id="39" name="Text 36"/>
+          <p:cNvSpPr txBox="1"/>
+          <p:nvPr/>
+        </p:nvSpPr>
+        <p:spPr>
+          <a:xfrm>
+            <a:off x="4663440" y="4297680"/>
+            <a:ext cx="2834640" cy="420624"/>
+          </a:xfrm>
+          <a:prstGeom prst="rect">
+            <a:avLst/>
+          </a:prstGeom>
+          <a:noFill/>
+          <a:ln/>
+        </p:spPr>
+        <p:txBody>
+          <a:bodyPr wrap="square" lIns="0" tIns="0" rIns="0" bIns="0" rtlCol="0" anchor="ctr"/>
+          <a:lstStyle/>
+          <a:p>
+            <a:pPr indent="0" marL="0">
+              <a:buNone/>
+            </a:pPr>
+            <a:r>
+              <a:rPr lang="en-US" sz="1400" b="1" dirty="0">
+                <a:solidFill>
+                  <a:srgbClr val="2B2D31"/>
+                </a:solidFill>
+                <a:latin typeface="맑은 고딕" pitchFamily="34" charset="0"/>
+                <a:ea typeface="맑은 고딕" pitchFamily="34" charset="-122"/>
+                <a:cs typeface="맑은 고딕" pitchFamily="34" charset="-120"/>
+              </a:rPr>
+              <a:t>안전   </a:t>
+            </a:r>
+            <a:pPr indent="0" marL="0">
+              <a:buNone/>
+            </a:pPr>
+            <a:r>
+              <a:rPr lang="en-US" sz="1200" dirty="0">
+                <a:solidFill>
+                  <a:srgbClr val="6B6F76"/>
+                </a:solidFill>
+                <a:latin typeface="맑은 고딕" pitchFamily="34" charset="0"/>
+                <a:ea typeface="맑은 고딕" pitchFamily="34" charset="-122"/>
+                <a:cs typeface="맑은 고딕" pitchFamily="34" charset="-120"/>
+              </a:rPr>
+              <a:t>놓친 부식 → 사고</a:t>
+            </a:r>
+            <a:endParaRPr lang="en-US" sz="1400" dirty="0"/>
+          </a:p>
+        </p:txBody>
+      </p:sp>
+      <p:sp>
+        <p:nvSpPr>
+          <p:cNvPr id="40" name="Shape 37"/>
+          <p:cNvSpPr/>
+          <p:nvPr/>
+        </p:nvSpPr>
+        <p:spPr>
+          <a:xfrm>
+            <a:off x="4114800" y="4864608"/>
+            <a:ext cx="420624" cy="420624"/>
+          </a:xfrm>
+          <a:prstGeom prst="ellipse">
+            <a:avLst/>
+          </a:prstGeom>
+          <a:solidFill>
+            <a:srgbClr val="2B2D31"/>
+          </a:solidFill>
+          <a:ln w="12700">
+            <a:solidFill>
+              <a:srgbClr val="2B2D31"/>
+            </a:solidFill>
+            <a:prstDash val="solid"/>
+          </a:ln>
+        </p:spPr>
+      </p:sp>
+      <p:pic>
+        <p:nvPicPr>
+          <p:cNvPr id="41" name="Image 1" descr="preencoded.png">    </p:cNvPr>
+          <p:cNvPicPr>
+            <a:picLocks noChangeAspect="1"/>
+          </p:cNvPicPr>
+          <p:nvPr/>
+        </p:nvPicPr>
+        <p:blipFill>
+          <a:blip r:embed="rId2"/>
+          <a:stretch>
+            <a:fillRect/>
+          </a:stretch>
+        </p:blipFill>
+        <p:spPr>
+          <a:xfrm>
+            <a:off x="4224162" y="4973970"/>
+            <a:ext cx="201900" cy="201900"/>
+          </a:xfrm>
+          <a:prstGeom prst="rect">
+            <a:avLst/>
+          </a:prstGeom>
+        </p:spPr>
+      </p:pic>
+      <p:sp>
+        <p:nvSpPr>
+          <p:cNvPr id="42" name="Text 38"/>
+          <p:cNvSpPr txBox="1"/>
+          <p:nvPr/>
+        </p:nvSpPr>
+        <p:spPr>
+          <a:xfrm>
+            <a:off x="4663440" y="4864608"/>
+            <a:ext cx="2834640" cy="420624"/>
+          </a:xfrm>
+          <a:prstGeom prst="rect">
+            <a:avLst/>
+          </a:prstGeom>
+          <a:noFill/>
+          <a:ln/>
+        </p:spPr>
+        <p:txBody>
+          <a:bodyPr wrap="square" lIns="0" tIns="0" rIns="0" bIns="0" rtlCol="0" anchor="ctr"/>
+          <a:lstStyle/>
+          <a:p>
+            <a:pPr indent="0" marL="0">
+              <a:buNone/>
+            </a:pPr>
+            <a:r>
+              <a:rPr lang="en-US" sz="1400" b="1" dirty="0">
+                <a:solidFill>
+                  <a:srgbClr val="2B2D31"/>
+                </a:solidFill>
+                <a:latin typeface="맑은 고딕" pitchFamily="34" charset="0"/>
+                <a:ea typeface="맑은 고딕" pitchFamily="34" charset="-122"/>
+                <a:cs typeface="맑은 고딕" pitchFamily="34" charset="-120"/>
+              </a:rPr>
+              <a:t>비용   </a:t>
+            </a:r>
+            <a:pPr indent="0" marL="0">
+              <a:buNone/>
+            </a:pPr>
+            <a:r>
+              <a:rPr lang="en-US" sz="1200" dirty="0">
+                <a:solidFill>
+                  <a:srgbClr val="6B6F76"/>
+                </a:solidFill>
+                <a:latin typeface="맑은 고딕" pitchFamily="34" charset="0"/>
+                <a:ea typeface="맑은 고딕" pitchFamily="34" charset="-122"/>
+                <a:cs typeface="맑은 고딕" pitchFamily="34" charset="-120"/>
+              </a:rPr>
+              <a:t>선박 · 리프트 일수</a:t>
+            </a:r>
+            <a:endParaRPr lang="en-US" sz="1400" dirty="0"/>
+          </a:p>
+        </p:txBody>
+      </p:sp>
+      <p:sp>
+        <p:nvSpPr>
+          <p:cNvPr id="43" name="Shape 39"/>
+          <p:cNvSpPr/>
+          <p:nvPr/>
+        </p:nvSpPr>
+        <p:spPr>
+          <a:xfrm>
+            <a:off x="4114800" y="5431536"/>
+            <a:ext cx="420624" cy="420624"/>
+          </a:xfrm>
+          <a:prstGeom prst="ellipse">
+            <a:avLst/>
+          </a:prstGeom>
+          <a:solidFill>
+            <a:srgbClr val="2B2D31"/>
+          </a:solidFill>
+          <a:ln w="12700">
+            <a:solidFill>
+              <a:srgbClr val="2B2D31"/>
+            </a:solidFill>
+            <a:prstDash val="solid"/>
+          </a:ln>
+        </p:spPr>
+      </p:sp>
+      <p:pic>
+        <p:nvPicPr>
+          <p:cNvPr id="44" name="Image 2" descr="preencoded.png">    </p:cNvPr>
+          <p:cNvPicPr>
+            <a:picLocks noChangeAspect="1"/>
+          </p:cNvPicPr>
+          <p:nvPr/>
+        </p:nvPicPr>
+        <p:blipFill>
+          <a:blip r:embed="rId3"/>
+          <a:stretch>
+            <a:fillRect/>
+          </a:stretch>
+        </p:blipFill>
+        <p:spPr>
+          <a:xfrm>
+            <a:off x="4224162" y="5540898"/>
+            <a:ext cx="201900" cy="201900"/>
+          </a:xfrm>
+          <a:prstGeom prst="rect">
+            <a:avLst/>
+          </a:prstGeom>
+        </p:spPr>
+      </p:pic>
+      <p:sp>
+        <p:nvSpPr>
+          <p:cNvPr id="45" name="Text 40"/>
+          <p:cNvSpPr txBox="1"/>
+          <p:nvPr/>
+        </p:nvSpPr>
+        <p:spPr>
+          <a:xfrm>
+            <a:off x="4663440" y="5431536"/>
+            <a:ext cx="2834640" cy="420624"/>
+          </a:xfrm>
+          <a:prstGeom prst="rect">
+            <a:avLst/>
+          </a:prstGeom>
+          <a:noFill/>
+          <a:ln/>
+        </p:spPr>
+        <p:txBody>
+          <a:bodyPr wrap="square" lIns="0" tIns="0" rIns="0" bIns="0" rtlCol="0" anchor="ctr"/>
+          <a:lstStyle/>
+          <a:p>
+            <a:pPr indent="0" marL="0">
+              <a:buNone/>
+            </a:pPr>
+            <a:r>
+              <a:rPr lang="en-US" sz="1400" b="1" dirty="0">
+                <a:solidFill>
+                  <a:srgbClr val="2B2D31"/>
+                </a:solidFill>
+                <a:latin typeface="맑은 고딕" pitchFamily="34" charset="0"/>
+                <a:ea typeface="맑은 고딕" pitchFamily="34" charset="-122"/>
+                <a:cs typeface="맑은 고딕" pitchFamily="34" charset="-120"/>
+              </a:rPr>
+              <a:t>규제 · 보험   </a:t>
+            </a:r>
+            <a:pPr indent="0" marL="0">
+              <a:buNone/>
+            </a:pPr>
+            <a:r>
+              <a:rPr lang="en-US" sz="1200" dirty="0">
+                <a:solidFill>
+                  <a:srgbClr val="6B6F76"/>
+                </a:solidFill>
+                <a:latin typeface="맑은 고딕" pitchFamily="34" charset="0"/>
+                <a:ea typeface="맑은 고딕" pitchFamily="34" charset="-122"/>
+                <a:cs typeface="맑은 고딕" pitchFamily="34" charset="-120"/>
+              </a:rPr>
+              <a:t>기한 내 기록 제출</a:t>
+            </a:r>
+            <a:endParaRPr lang="en-US" sz="1400" dirty="0"/>
+          </a:p>
+        </p:txBody>
+      </p:sp>
+      <p:sp>
+        <p:nvSpPr>
+          <p:cNvPr id="46" name="Shape 41"/>
+          <p:cNvSpPr/>
+          <p:nvPr/>
+        </p:nvSpPr>
+        <p:spPr>
+          <a:xfrm>
+            <a:off x="7955280" y="3703320"/>
+            <a:ext cx="3687775" cy="2377440"/>
           </a:xfrm>
           <a:prstGeom prst="roundRect">
             <a:avLst>
-              <a:gd name="adj" fmla="val 11538"/>
-            </a:avLst>
-          </a:prstGeom>
-          <a:solidFill>
-            <a:srgbClr val="FFF6DB"/>
-          </a:solidFill>
-          <a:ln w="15875">
-            <a:solidFill>
-              <a:srgbClr val="E0B23C"/>
-            </a:solidFill>
-            <a:prstDash val="dash"/>
-          </a:ln>
-        </p:spPr>
-      </p:sp>
-      <p:sp>
-        <p:nvSpPr>
-          <p:cNvPr id="38" name="Text 36"/>
-          <p:cNvSpPr txBox="1"/>
-          <p:nvPr/>
-        </p:nvSpPr>
-        <p:spPr>
-          <a:xfrm>
-            <a:off x="1554480" y="4882896"/>
-            <a:ext cx="6309360" cy="475488"/>
-          </a:xfrm>
-          <a:prstGeom prst="rect">
-            <a:avLst/>
-          </a:prstGeom>
-          <a:noFill/>
-          <a:ln/>
-        </p:spPr>
-        <p:txBody>
-          <a:bodyPr wrap="square" lIns="0" tIns="0" rIns="0" bIns="0" rtlCol="0" anchor="ctr"/>
-          <a:lstStyle/>
-          <a:p>
-            <a:pPr marL="0" indent="0">
-              <a:buNone/>
-            </a:pPr>
-            <a:r>
-              <a:rPr lang="en-US" sz="1150" dirty="0">
-                <a:solidFill>
-                  <a:srgbClr val="9A6A00"/>
-                </a:solidFill>
-                <a:latin typeface="맑은 고딕" pitchFamily="34" charset="0"/>
-                <a:ea typeface="맑은 고딕" pitchFamily="34" charset="-122"/>
-                <a:cs typeface="맑은 고딕" pitchFamily="34" charset="-120"/>
-              </a:rPr>
-              <a:t>✎  첫 3년: 파일럿 고객 수 × 연간 스캔 구조물 수 × 단가</a:t>
-            </a:r>
-            <a:endParaRPr lang="en-US" sz="1150" dirty="0"/>
-          </a:p>
-        </p:txBody>
-      </p:sp>
-      <p:sp>
-        <p:nvSpPr>
-          <p:cNvPr id="39" name="Shape 37"/>
-          <p:cNvSpPr/>
-          <p:nvPr/>
-        </p:nvSpPr>
-        <p:spPr>
-          <a:xfrm>
-            <a:off x="8275320" y="3749040"/>
-            <a:ext cx="3367735" cy="1609344"/>
-          </a:xfrm>
-          <a:prstGeom prst="roundRect">
-            <a:avLst>
-              <a:gd name="adj" fmla="val 4545"/>
+              <a:gd name="adj" fmla="val 3077"/>
             </a:avLst>
           </a:prstGeom>
           <a:solidFill>
             <a:srgbClr val="E3EFF4"/>
           </a:solidFill>
-          <a:ln w="6350">
+          <a:ln w="12700">
             <a:solidFill>
               <a:srgbClr val="E3EFF4"/>
             </a:solidFill>
@@ -12648,14 +13167,14 @@
       </p:sp>
       <p:sp>
         <p:nvSpPr>
-          <p:cNvPr id="40" name="Text 38"/>
-          <p:cNvSpPr txBox="1"/>
-          <p:nvPr/>
-        </p:nvSpPr>
-        <p:spPr>
-          <a:xfrm>
-            <a:off x="8503920" y="3886200"/>
-            <a:ext cx="3001975" cy="274320"/>
+          <p:cNvPr id="47" name="Text 42"/>
+          <p:cNvSpPr txBox="1"/>
+          <p:nvPr/>
+        </p:nvSpPr>
+        <p:spPr>
+          <a:xfrm>
+            <a:off x="8229600" y="3886200"/>
+            <a:ext cx="3230575" cy="292608"/>
           </a:xfrm>
           <a:prstGeom prst="rect">
             <a:avLst/>
@@ -12667,11 +13186,11 @@
           <a:bodyPr wrap="square" lIns="0" tIns="0" rIns="0" bIns="0" rtlCol="0" anchor="t"/>
           <a:lstStyle/>
           <a:p>
-            <a:pPr marL="0" indent="0">
-              <a:buNone/>
-            </a:pPr>
-            <a:r>
-              <a:rPr lang="en-US" sz="1250" b="1" dirty="0">
+            <a:pPr indent="0" marL="0">
+              <a:buNone/>
+            </a:pPr>
+            <a:r>
+              <a:rPr lang="en-US" sz="1300" b="1" dirty="0">
                 <a:solidFill>
                   <a:srgbClr val="1F5F7A"/>
                 </a:solidFill>
@@ -12679,22 +13198,61 @@
                 <a:ea typeface="맑은 고딕" pitchFamily="34" charset="-122"/>
                 <a:cs typeface="맑은 고딕" pitchFamily="34" charset="-120"/>
               </a:rPr>
-              <a:t>국내 확장 후보 (검증 예정)</a:t>
-            </a:r>
-            <a:endParaRPr lang="en-US" sz="1250" dirty="0"/>
-          </a:p>
-        </p:txBody>
-      </p:sp>
-      <p:sp>
-        <p:nvSpPr>
-          <p:cNvPr id="41" name="Shape 39"/>
+              <a:t>진입 순서</a:t>
+            </a:r>
+            <a:endParaRPr lang="en-US" sz="1300" dirty="0"/>
+          </a:p>
+        </p:txBody>
+      </p:sp>
+      <p:sp>
+        <p:nvSpPr>
+          <p:cNvPr id="48" name="Text 43"/>
+          <p:cNvSpPr txBox="1"/>
+          <p:nvPr/>
+        </p:nvSpPr>
+        <p:spPr>
+          <a:xfrm>
+            <a:off x="8229600" y="4297680"/>
+            <a:ext cx="274320" cy="420624"/>
+          </a:xfrm>
+          <a:prstGeom prst="rect">
+            <a:avLst/>
+          </a:prstGeom>
+          <a:noFill/>
+          <a:ln/>
+        </p:spPr>
+        <p:txBody>
+          <a:bodyPr wrap="square" lIns="0" tIns="0" rIns="0" bIns="0" rtlCol="0" anchor="ctr"/>
+          <a:lstStyle/>
+          <a:p>
+            <a:pPr indent="0" marL="0">
+              <a:buNone/>
+            </a:pPr>
+            <a:r>
+              <a:rPr lang="en-US" sz="1600" b="1" dirty="0">
+                <a:solidFill>
+                  <a:srgbClr val="1F5F7A"/>
+                </a:solidFill>
+                <a:latin typeface="맑은 고딕" pitchFamily="34" charset="0"/>
+                <a:ea typeface="맑은 고딕" pitchFamily="34" charset="-122"/>
+                <a:cs typeface="맑은 고딕" pitchFamily="34" charset="-120"/>
+              </a:rPr>
+              <a:t>1</a:t>
+            </a:r>
+            <a:endParaRPr lang="en-US" sz="1600" dirty="0"/>
+          </a:p>
+        </p:txBody>
+      </p:sp>
+      <p:sp>
+        <p:nvSpPr>
+          <p:cNvPr id="49" name="Shape 44"/>
           <p:cNvSpPr/>
           <p:nvPr/>
         </p:nvSpPr>
         <p:spPr>
           <a:xfrm>
-            <a:off x="8503920" y="4297680"/>
-            <a:ext cx="384048" cy="384048"/>
+            <a:off x="8549640" y="4297680"/>
+            <a:ext cx="420624" cy="420624"/>
           </a:xfrm>
           <a:prstGeom prst="ellipse">
             <a:avLst/>
@@ -12712,22 +13270,22 @@
       </p:sp>
       <p:pic>
         <p:nvPicPr>
-          <p:cNvPr id="42" name="Image 0" descr="preencoded.png"/>
+          <p:cNvPr id="50" name="Image 3" descr="preencoded.png">    </p:cNvPr>
           <p:cNvPicPr>
             <a:picLocks noChangeAspect="1"/>
           </p:cNvPicPr>
           <p:nvPr/>
         </p:nvPicPr>
         <p:blipFill>
-          <a:blip r:embed="rId3"/>
+          <a:blip r:embed="rId4"/>
           <a:stretch>
             <a:fillRect/>
           </a:stretch>
         </p:blipFill>
         <p:spPr>
           <a:xfrm>
-            <a:off x="8603772" y="4397532"/>
-            <a:ext cx="184343" cy="184343"/>
+            <a:off x="8659002" y="4407042"/>
+            <a:ext cx="201900" cy="201900"/>
           </a:xfrm>
           <a:prstGeom prst="rect">
             <a:avLst/>
@@ -12736,14 +13294,14 @@
       </p:pic>
       <p:sp>
         <p:nvSpPr>
-          <p:cNvPr id="43" name="Text 40"/>
-          <p:cNvSpPr txBox="1"/>
-          <p:nvPr/>
-        </p:nvSpPr>
-        <p:spPr>
-          <a:xfrm>
-            <a:off x="9006840" y="4297680"/>
-            <a:ext cx="2544775" cy="384048"/>
+          <p:cNvPr id="51" name="Text 45"/>
+          <p:cNvSpPr txBox="1"/>
+          <p:nvPr/>
+        </p:nvSpPr>
+        <p:spPr>
+          <a:xfrm>
+            <a:off x="9098280" y="4297680"/>
+            <a:ext cx="2407615" cy="420624"/>
           </a:xfrm>
           <a:prstGeom prst="rect">
             <a:avLst/>
@@ -12755,11 +13313,11 @@
           <a:bodyPr wrap="square" lIns="0" tIns="0" rIns="0" bIns="0" rtlCol="0" anchor="ctr"/>
           <a:lstStyle/>
           <a:p>
-            <a:pPr marL="0" indent="0">
-              <a:buNone/>
-            </a:pPr>
-            <a:r>
-              <a:rPr lang="en-US" sz="1300" dirty="0">
+            <a:pPr indent="0" marL="0">
+              <a:buNone/>
+            </a:pPr>
+            <a:r>
+              <a:rPr lang="en-US" sz="1350" dirty="0">
                 <a:solidFill>
                   <a:srgbClr val="2B2D31"/>
                 </a:solidFill>
@@ -12767,22 +13325,61 @@
                 <a:ea typeface="맑은 고딕" pitchFamily="34" charset="-122"/>
                 <a:cs typeface="맑은 고딕" pitchFamily="34" charset="-120"/>
               </a:rPr>
-              <a:t>해상풍력 하부 구조</a:t>
-            </a:r>
-            <a:endParaRPr lang="en-US" sz="1300" dirty="0"/>
-          </a:p>
-        </p:txBody>
-      </p:sp>
-      <p:sp>
-        <p:nvSpPr>
-          <p:cNvPr id="44" name="Shape 41"/>
+              <a:t>멕시코만 해양 플랫폼</a:t>
+            </a:r>
+            <a:endParaRPr lang="en-US" sz="1350" dirty="0"/>
+          </a:p>
+        </p:txBody>
+      </p:sp>
+      <p:sp>
+        <p:nvSpPr>
+          <p:cNvPr id="52" name="Text 46"/>
+          <p:cNvSpPr txBox="1"/>
+          <p:nvPr/>
+        </p:nvSpPr>
+        <p:spPr>
+          <a:xfrm>
+            <a:off x="8229600" y="4864608"/>
+            <a:ext cx="274320" cy="420624"/>
+          </a:xfrm>
+          <a:prstGeom prst="rect">
+            <a:avLst/>
+          </a:prstGeom>
+          <a:noFill/>
+          <a:ln/>
+        </p:spPr>
+        <p:txBody>
+          <a:bodyPr wrap="square" lIns="0" tIns="0" rIns="0" bIns="0" rtlCol="0" anchor="ctr"/>
+          <a:lstStyle/>
+          <a:p>
+            <a:pPr indent="0" marL="0">
+              <a:buNone/>
+            </a:pPr>
+            <a:r>
+              <a:rPr lang="en-US" sz="1600" b="1" dirty="0">
+                <a:solidFill>
+                  <a:srgbClr val="1F5F7A"/>
+                </a:solidFill>
+                <a:latin typeface="맑은 고딕" pitchFamily="34" charset="0"/>
+                <a:ea typeface="맑은 고딕" pitchFamily="34" charset="-122"/>
+                <a:cs typeface="맑은 고딕" pitchFamily="34" charset="-120"/>
+              </a:rPr>
+              <a:t>2</a:t>
+            </a:r>
+            <a:endParaRPr lang="en-US" sz="1600" dirty="0"/>
+          </a:p>
+        </p:txBody>
+      </p:sp>
+      <p:sp>
+        <p:nvSpPr>
+          <p:cNvPr id="53" name="Shape 47"/>
           <p:cNvSpPr/>
           <p:nvPr/>
         </p:nvSpPr>
         <p:spPr>
           <a:xfrm>
-            <a:off x="8503920" y="4800600"/>
-            <a:ext cx="384048" cy="384048"/>
+            <a:off x="8549640" y="4864608"/>
+            <a:ext cx="420624" cy="420624"/>
           </a:xfrm>
           <a:prstGeom prst="ellipse">
             <a:avLst/>
@@ -12800,22 +13397,22 @@
       </p:sp>
       <p:pic>
         <p:nvPicPr>
-          <p:cNvPr id="45" name="Image 1" descr="preencoded.png"/>
+          <p:cNvPr id="54" name="Image 4" descr="preencoded.png">    </p:cNvPr>
           <p:cNvPicPr>
             <a:picLocks noChangeAspect="1"/>
           </p:cNvPicPr>
           <p:nvPr/>
         </p:nvPicPr>
         <p:blipFill>
-          <a:blip r:embed="rId4"/>
+          <a:blip r:embed="rId5"/>
           <a:stretch>
             <a:fillRect/>
           </a:stretch>
         </p:blipFill>
         <p:spPr>
           <a:xfrm>
-            <a:off x="8603772" y="4900452"/>
-            <a:ext cx="184343" cy="184343"/>
+            <a:off x="8659002" y="4973970"/>
+            <a:ext cx="201900" cy="201900"/>
           </a:xfrm>
           <a:prstGeom prst="rect">
             <a:avLst/>
@@ -12824,14 +13421,14 @@
       </p:pic>
       <p:sp>
         <p:nvSpPr>
-          <p:cNvPr id="46" name="Text 42"/>
-          <p:cNvSpPr txBox="1"/>
-          <p:nvPr/>
-        </p:nvSpPr>
-        <p:spPr>
-          <a:xfrm>
-            <a:off x="9006840" y="4800600"/>
-            <a:ext cx="2544775" cy="384048"/>
+          <p:cNvPr id="55" name="Text 48"/>
+          <p:cNvSpPr txBox="1"/>
+          <p:nvPr/>
+        </p:nvSpPr>
+        <p:spPr>
+          <a:xfrm>
+            <a:off x="9098280" y="4864608"/>
+            <a:ext cx="2407615" cy="420624"/>
           </a:xfrm>
           <a:prstGeom prst="rect">
             <a:avLst/>
@@ -12843,11 +13440,11 @@
           <a:bodyPr wrap="square" lIns="0" tIns="0" rIns="0" bIns="0" rtlCol="0" anchor="ctr"/>
           <a:lstStyle/>
           <a:p>
-            <a:pPr marL="0" indent="0">
-              <a:buNone/>
-            </a:pPr>
-            <a:r>
-              <a:rPr lang="en-US" sz="1300" dirty="0">
+            <a:pPr indent="0" marL="0">
+              <a:buNone/>
+            </a:pPr>
+            <a:r>
+              <a:rPr lang="en-US" sz="1350" dirty="0">
                 <a:solidFill>
                   <a:srgbClr val="2B2D31"/>
                 </a:solidFill>
@@ -12855,9 +13452,136 @@
                 <a:ea typeface="맑은 고딕" pitchFamily="34" charset="-122"/>
                 <a:cs typeface="맑은 고딕" pitchFamily="34" charset="-120"/>
               </a:rPr>
-              <a:t>해양 플랜트 · 조선 · 항만</a:t>
-            </a:r>
-            <a:endParaRPr lang="en-US" sz="1300" dirty="0"/>
+              <a:t>미드스트림 가스 압축 기지</a:t>
+            </a:r>
+            <a:endParaRPr lang="en-US" sz="1350" dirty="0"/>
+          </a:p>
+        </p:txBody>
+      </p:sp>
+      <p:sp>
+        <p:nvSpPr>
+          <p:cNvPr id="56" name="Text 49"/>
+          <p:cNvSpPr txBox="1"/>
+          <p:nvPr/>
+        </p:nvSpPr>
+        <p:spPr>
+          <a:xfrm>
+            <a:off x="8229600" y="5431536"/>
+            <a:ext cx="274320" cy="420624"/>
+          </a:xfrm>
+          <a:prstGeom prst="rect">
+            <a:avLst/>
+          </a:prstGeom>
+          <a:noFill/>
+          <a:ln/>
+        </p:spPr>
+        <p:txBody>
+          <a:bodyPr wrap="square" lIns="0" tIns="0" rIns="0" bIns="0" rtlCol="0" anchor="ctr"/>
+          <a:lstStyle/>
+          <a:p>
+            <a:pPr indent="0" marL="0">
+              <a:buNone/>
+            </a:pPr>
+            <a:r>
+              <a:rPr lang="en-US" sz="1600" b="1" dirty="0">
+                <a:solidFill>
+                  <a:srgbClr val="1F5F7A"/>
+                </a:solidFill>
+                <a:latin typeface="맑은 고딕" pitchFamily="34" charset="0"/>
+                <a:ea typeface="맑은 고딕" pitchFamily="34" charset="-122"/>
+                <a:cs typeface="맑은 고딕" pitchFamily="34" charset="-120"/>
+              </a:rPr>
+              <a:t>3</a:t>
+            </a:r>
+            <a:endParaRPr lang="en-US" sz="1600" dirty="0"/>
+          </a:p>
+        </p:txBody>
+      </p:sp>
+      <p:sp>
+        <p:nvSpPr>
+          <p:cNvPr id="57" name="Shape 50"/>
+          <p:cNvSpPr/>
+          <p:nvPr/>
+        </p:nvSpPr>
+        <p:spPr>
+          <a:xfrm>
+            <a:off x="8549640" y="5431536"/>
+            <a:ext cx="420624" cy="420624"/>
+          </a:xfrm>
+          <a:prstGeom prst="ellipse">
+            <a:avLst/>
+          </a:prstGeom>
+          <a:solidFill>
+            <a:srgbClr val="1F5F7A"/>
+          </a:solidFill>
+          <a:ln w="12700">
+            <a:solidFill>
+              <a:srgbClr val="1F5F7A"/>
+            </a:solidFill>
+            <a:prstDash val="solid"/>
+          </a:ln>
+        </p:spPr>
+      </p:sp>
+      <p:pic>
+        <p:nvPicPr>
+          <p:cNvPr id="58" name="Image 5" descr="preencoded.png">    </p:cNvPr>
+          <p:cNvPicPr>
+            <a:picLocks noChangeAspect="1"/>
+          </p:cNvPicPr>
+          <p:nvPr/>
+        </p:nvPicPr>
+        <p:blipFill>
+          <a:blip r:embed="rId6"/>
+          <a:stretch>
+            <a:fillRect/>
+          </a:stretch>
+        </p:blipFill>
+        <p:spPr>
+          <a:xfrm>
+            <a:off x="8659002" y="5540898"/>
+            <a:ext cx="201900" cy="201900"/>
+          </a:xfrm>
+          <a:prstGeom prst="rect">
+            <a:avLst/>
+          </a:prstGeom>
+        </p:spPr>
+      </p:pic>
+      <p:sp>
+        <p:nvSpPr>
+          <p:cNvPr id="59" name="Text 51"/>
+          <p:cNvSpPr txBox="1"/>
+          <p:nvPr/>
+        </p:nvSpPr>
+        <p:spPr>
+          <a:xfrm>
+            <a:off x="9098280" y="5431536"/>
+            <a:ext cx="2407615" cy="420624"/>
+          </a:xfrm>
+          <a:prstGeom prst="rect">
+            <a:avLst/>
+          </a:prstGeom>
+          <a:noFill/>
+          <a:ln/>
+        </p:spPr>
+        <p:txBody>
+          <a:bodyPr wrap="square" lIns="0" tIns="0" rIns="0" bIns="0" rtlCol="0" anchor="ctr"/>
+          <a:lstStyle/>
+          <a:p>
+            <a:pPr indent="0" marL="0">
+              <a:buNone/>
+            </a:pPr>
+            <a:r>
+              <a:rPr lang="en-US" sz="1350" dirty="0">
+                <a:solidFill>
+                  <a:srgbClr val="2B2D31"/>
+                </a:solidFill>
+                <a:latin typeface="맑은 고딕" pitchFamily="34" charset="0"/>
+                <a:ea typeface="맑은 고딕" pitchFamily="34" charset="-122"/>
+                <a:cs typeface="맑은 고딕" pitchFamily="34" charset="-120"/>
+              </a:rPr>
+              <a:t>국내 해상풍력 · 해양 플랜트</a:t>
+            </a:r>
+            <a:endParaRPr lang="en-US" sz="1350" dirty="0"/>
           </a:p>
         </p:txBody>
       </p:sp>

</xml_diff>